<commit_message>
Consolidate Aug 2026 workspace updates to GitHub.
Pricing/book-B pipeline, derived metrics, dashboards, DB sales review tooling, IDS packs, meeting deliverables, and Cursor rules/skills.

Co-authored-by: Cursor <cursoragent@cursor.com>
</commit_message>
<xml_diff>
--- a/09_meetings/IBX_Sales_Review_2026/ISZE_IBX_Sales_Review_FY2027_ModeA_only.pptx
+++ b/09_meetings/IBX_Sales_Review_2026/ISZE_IBX_Sales_Review_FY2027_ModeA_only.pptx
@@ -24,7 +24,6 @@
     <p:sldId id="272" r:id="rId23"/>
     <p:sldId id="273" r:id="rId24"/>
     <p:sldId id="274" r:id="rId25"/>
-    <p:sldId id="275" r:id="rId26"/>
   </p:sldIdLst>
   <p:sldSz cx="12188952" cy="6858000" type="screen4x3"/>
   <p:notesSz cx="6858000" cy="9144000"/>
@@ -3489,7 +3488,7 @@
                 </a:solidFill>
                 <a:latin typeface="Calibri"/>
               </a:rPr>
-              <a:t>GPS Capture: 85.2%</a:t>
+              <a:t>GPS Capture: 76.1%</a:t>
             </a:r>
           </a:p>
         </p:txBody>
@@ -3581,7 +3580,7 @@
         <p:spPr>
           <a:xfrm>
             <a:off x="292608" y="1234440"/>
-            <a:ext cx="10515600" cy="3200400"/>
+            <a:ext cx="10515600" cy="3657600"/>
           </a:xfrm>
           <a:prstGeom prst="rect">
             <a:avLst/>
@@ -3603,7 +3602,7 @@
               </a:spcAft>
             </a:pPr>
             <a:r>
-              <a:rPr sz="1500" b="1">
+              <a:rPr sz="1400" b="1">
                 <a:solidFill>
                   <a:srgbClr val="CC0E1E"/>
                 </a:solidFill>
@@ -3612,7 +3611,7 @@
               <a:t>—  </a:t>
             </a:r>
             <a:r>
-              <a:rPr sz="1500">
+              <a:rPr sz="1400">
                 <a:solidFill>
                   <a:srgbClr val="1A1A1A"/>
                 </a:solidFill>
@@ -3631,7 +3630,7 @@
               </a:spcAft>
             </a:pPr>
             <a:r>
-              <a:rPr sz="1500" b="1">
+              <a:rPr sz="1400" b="1">
                 <a:solidFill>
                   <a:srgbClr val="CC0E1E"/>
                 </a:solidFill>
@@ -3640,13 +3639,13 @@
               <a:t>—  </a:t>
             </a:r>
             <a:r>
-              <a:rPr sz="1500">
+              <a:rPr sz="1400">
                 <a:solidFill>
                   <a:srgbClr val="1A1A1A"/>
                 </a:solidFill>
                 <a:latin typeface="Calibri"/>
               </a:rPr>
-              <a:t>Benelux today: 85.2% (FY2026 purchases against the CY2025 fleet potential).</a:t>
+              <a:t>Benelux today: 76.1% (FY2026 purchases against the CY2025 fleet potential).</a:t>
             </a:r>
           </a:p>
           <a:p>
@@ -3659,7 +3658,7 @@
               </a:spcAft>
             </a:pPr>
             <a:r>
-              <a:rPr sz="1500" b="1">
+              <a:rPr sz="1400" b="1">
                 <a:solidFill>
                   <a:srgbClr val="CC0E1E"/>
                 </a:solidFill>
@@ -3668,13 +3667,13 @@
               <a:t>—  </a:t>
             </a:r>
             <a:r>
-              <a:rPr sz="1500">
+              <a:rPr sz="1400">
                 <a:solidFill>
                   <a:srgbClr val="1A1A1A"/>
                 </a:solidFill>
                 <a:latin typeface="Calibri"/>
               </a:rPr>
-              <a:t>Fleet potential: EUR 2,454K on 9,593 vehicles.</a:t>
+              <a:t>Fleet potential: EUR 2,745K on 10,760 vehicles.</a:t>
             </a:r>
           </a:p>
           <a:p>
@@ -3687,7 +3686,7 @@
               </a:spcAft>
             </a:pPr>
             <a:r>
-              <a:rPr sz="1500" b="1">
+              <a:rPr sz="1400" b="1">
                 <a:solidFill>
                   <a:srgbClr val="CC0E1E"/>
                 </a:solidFill>
@@ -3696,13 +3695,41 @@
               <a:t>—  </a:t>
             </a:r>
             <a:r>
-              <a:rPr sz="1500">
+              <a:rPr sz="1400">
                 <a:solidFill>
                   <a:srgbClr val="1A1A1A"/>
                 </a:solidFill>
                 <a:latin typeface="Calibri"/>
               </a:rPr>
-              <a:t>Real, sustained headroom above 85.2% — the service-parts and SPA discussion are both direct levers on it.</a:t>
+              <a:t>Denominator widened vs Belgium-only file: Poland UIO10 (Łukasz / SAMAR 2025): +1,167 UIO (base was 9,593 / EUR 2,454K). NL/LUX still 0 in carpark.</a:t>
+            </a:r>
+          </a:p>
+          <a:p>
+            <a:pPr>
+              <a:lnSpc>
+                <a:spcPct val="125000"/>
+              </a:lnSpc>
+              <a:spcAft>
+                <a:spcPts val="1000"/>
+              </a:spcAft>
+            </a:pPr>
+            <a:r>
+              <a:rPr sz="1400" b="1">
+                <a:solidFill>
+                  <a:srgbClr val="CC0E1E"/>
+                </a:solidFill>
+                <a:latin typeface="Calibri"/>
+              </a:rPr>
+              <a:t>—  </a:t>
+            </a:r>
+            <a:r>
+              <a:rPr sz="1400">
+                <a:solidFill>
+                  <a:srgbClr val="1A1A1A"/>
+                </a:solidFill>
+                <a:latin typeface="Calibri"/>
+              </a:rPr>
+              <a:t>Q1 FY2027 IBX order mix ~39% SOR / ~39% VOR by € — VOR urgency pricing lifts billed amount.</a:t>
             </a:r>
           </a:p>
         </p:txBody>
@@ -5700,7 +5727,7 @@
                 </a:solidFill>
                 <a:latin typeface="Calibri"/>
               </a:rPr>
-              <a:t>The FY2027 Sales-to-Dealer target starts from that fleet change, then applies a 5% price adjustment and 1.8% additional growth.</a:t>
+              <a:t>The FY2027 extended target (ISZE→DB) applies a 5% price adjustment and 1.8% stretch — locked at EUR 2,340,134 from GPS Extended Target V3.1 (Dashboard column I).</a:t>
             </a:r>
           </a:p>
           <a:p>
@@ -5891,7 +5918,7 @@
                 </a:solidFill>
                 <a:latin typeface="Calibri"/>
               </a:rPr>
-              <a:t>How the FY2027 target is built</a:t>
+              <a:t>How the FY2027 extended target is built</a:t>
             </a:r>
           </a:p>
         </p:txBody>
@@ -5983,7 +6010,7 @@
         <p:spPr>
           <a:xfrm>
             <a:off x="292608" y="1170432"/>
-            <a:ext cx="8595360" cy="274320"/>
+            <a:ext cx="10515600" cy="274320"/>
           </a:xfrm>
           <a:prstGeom prst="rect">
             <a:avLst/>
@@ -6004,7 +6031,7 @@
                 </a:solidFill>
                 <a:latin typeface="Calibri"/>
               </a:rPr>
-              <a:t>Sales-to-Dealer amount bridge</a:t>
+              <a:t>ISZE → DB extended target (V3.1 Dashboard column I)</a:t>
             </a:r>
           </a:p>
         </p:txBody>
@@ -6019,7 +6046,7 @@
         </p:nvGraphicFramePr>
         <p:xfrm>
           <a:off x="292608" y="1508760"/>
-          <a:ext cx="8595360" cy="2148840"/>
+          <a:ext cx="8595360" cy="2331720"/>
         </p:xfrm>
         <a:graphic>
           <a:graphicData uri="http://schemas.openxmlformats.org/drawingml/2006/table">
@@ -6031,7 +6058,7 @@
                 <a:gridCol w="5669280"/>
                 <a:gridCol w="2926080"/>
               </a:tblGrid>
-              <a:tr h="429768">
+              <a:tr h="466344">
                 <a:tc>
                   <a:txBody>
                     <a:bodyPr/>
@@ -6079,7 +6106,7 @@
                   </a:tcPr>
                 </a:tc>
               </a:tr>
-              <a:tr h="429768">
+              <a:tr h="466344">
                 <a:tc>
                   <a:txBody>
                     <a:bodyPr/>
@@ -6093,7 +6120,7 @@
                           </a:solidFill>
                           <a:latin typeface="Calibri"/>
                         </a:rPr>
-                        <a:t>FY2026 Sales-to-Dealer (reported KPI)</a:t>
+                        <a:t>Business Plan / actual FY27 base</a:t>
                       </a:r>
                     </a:p>
                   </a:txBody>
@@ -6116,7 +6143,7 @@
                           </a:solidFill>
                           <a:latin typeface="Calibri"/>
                         </a:rPr>
-                        <a:t>EUR 6,834,272</a:t>
+                        <a:t>EUR 2,296,577</a:t>
                       </a:r>
                     </a:p>
                   </a:txBody>
@@ -6127,7 +6154,7 @@
                   </a:tcPr>
                 </a:tc>
               </a:tr>
-              <a:tr h="429768">
+              <a:tr h="466344">
                 <a:tc>
                   <a:txBody>
                     <a:bodyPr/>
@@ -6141,7 +6168,7 @@
                           </a:solidFill>
                           <a:latin typeface="Calibri"/>
                         </a:rPr>
-                        <a:t>After fleet movement (-3.2%)</a:t>
+                        <a:t>Market potential (max spend FY27)</a:t>
                       </a:r>
                     </a:p>
                   </a:txBody>
@@ -6164,7 +6191,7 @@
                           </a:solidFill>
                           <a:latin typeface="Calibri"/>
                         </a:rPr>
-                        <a:t>EUR 6,618,408</a:t>
+                        <a:t>EUR 2,419,787</a:t>
                       </a:r>
                     </a:p>
                   </a:txBody>
@@ -6175,7 +6202,7 @@
                   </a:tcPr>
                 </a:tc>
               </a:tr>
-              <a:tr h="429768">
+              <a:tr h="466344">
                 <a:tc>
                   <a:txBody>
                     <a:bodyPr/>
@@ -6189,7 +6216,7 @@
                           </a:solidFill>
                           <a:latin typeface="Calibri"/>
                         </a:rPr>
-                        <a:t>After price adjustment (+5%)</a:t>
+                        <a:t>Stretch (+1.8% of max spend)</a:t>
                       </a:r>
                     </a:p>
                   </a:txBody>
@@ -6212,7 +6239,7 @@
                           </a:solidFill>
                           <a:latin typeface="Calibri"/>
                         </a:rPr>
-                        <a:t>EUR 6,949,328</a:t>
+                        <a:t>EUR 43,556</a:t>
                       </a:r>
                     </a:p>
                   </a:txBody>
@@ -6223,7 +6250,7 @@
                   </a:tcPr>
                 </a:tc>
               </a:tr>
-              <a:tr h="429768">
+              <a:tr h="466344">
                 <a:tc>
                   <a:txBody>
                     <a:bodyPr/>
@@ -6237,7 +6264,7 @@
                           </a:solidFill>
                           <a:latin typeface="Calibri"/>
                         </a:rPr>
-                        <a:t>FY2027 target after additional growth (+1.8%)</a:t>
+                        <a:t>FY2027 EXTENDED TARGET (locked)</a:t>
                       </a:r>
                     </a:p>
                   </a:txBody>
@@ -6260,7 +6287,7 @@
                           </a:solidFill>
                           <a:latin typeface="Calibri"/>
                         </a:rPr>
-                        <a:t>EUR 7,074,416</a:t>
+                        <a:t>EUR 2,340,134</a:t>
                       </a:r>
                     </a:p>
                   </a:txBody>
@@ -6283,8 +6310,8 @@
         </p:nvSpPr>
         <p:spPr>
           <a:xfrm>
-            <a:off x="292608" y="3977639"/>
-            <a:ext cx="11612880" cy="1188720"/>
+            <a:off x="292608" y="4069080"/>
+            <a:ext cx="11612880" cy="1280160"/>
           </a:xfrm>
           <a:prstGeom prst="rect">
             <a:avLst/>
@@ -6321,7 +6348,7 @@
                 </a:solidFill>
                 <a:latin typeface="Calibri"/>
               </a:rPr>
-              <a:t>The FY2027 target is +3.5% versus the FY2026 Sales-to-Dealer base.</a:t>
+              <a:t>Extended target = BP + stretch; stretch default is 1.8% (network rule from GPS Extended Target V3.1).</a:t>
             </a:r>
           </a:p>
           <a:p>
@@ -6349,7 +6376,7 @@
                 </a:solidFill>
                 <a:latin typeface="Calibri"/>
               </a:rPr>
-              <a:t>The FY2026 base is the reported Sales-to-Dealer KPI.</a:t>
+              <a:t>Figure locked from V3.1 Dashboard col I BELGIUM: EUR 2,340,134.</a:t>
             </a:r>
           </a:p>
         </p:txBody>
@@ -7038,7 +7065,7 @@
         </p:nvGraphicFramePr>
         <p:xfrm>
           <a:off x="292608" y="3785615"/>
-          <a:ext cx="8595360" cy="1234440"/>
+          <a:ext cx="8595360" cy="1417320"/>
         </p:xfrm>
         <a:graphic>
           <a:graphicData uri="http://schemas.openxmlformats.org/drawingml/2006/table">
@@ -7050,7 +7077,7 @@
                 <a:gridCol w="5029200"/>
                 <a:gridCol w="3566160"/>
               </a:tblGrid>
-              <a:tr h="411480">
+              <a:tr h="354330">
                 <a:tc>
                   <a:txBody>
                     <a:bodyPr/>
@@ -7098,7 +7125,7 @@
                   </a:tcPr>
                 </a:tc>
               </a:tr>
-              <a:tr h="411480">
+              <a:tr h="354330">
                 <a:tc>
                   <a:txBody>
                     <a:bodyPr/>
@@ -7112,7 +7139,7 @@
                           </a:solidFill>
                           <a:latin typeface="Calibri"/>
                         </a:rPr>
-                        <a:t>FY2027 Sales-to-Dealer target</a:t>
+                        <a:t>FY2027 extended target (V3.1 col I)</a:t>
                       </a:r>
                     </a:p>
                   </a:txBody>
@@ -7135,7 +7162,7 @@
                           </a:solidFill>
                           <a:latin typeface="Calibri"/>
                         </a:rPr>
-                        <a:t>EUR 7,074,416</a:t>
+                        <a:t>EUR 2,340,134</a:t>
                       </a:r>
                     </a:p>
                   </a:txBody>
@@ -7146,7 +7173,55 @@
                   </a:tcPr>
                 </a:tc>
               </a:tr>
-              <a:tr h="411480">
+              <a:tr h="354330">
+                <a:tc>
+                  <a:txBody>
+                    <a:bodyPr/>
+                    <a:lstStyle/>
+                    <a:p>
+                      <a:pPr algn="l"/>
+                      <a:r>
+                        <a:rPr sz="1250" b="0">
+                          <a:solidFill>
+                            <a:srgbClr val="1A1A1A"/>
+                          </a:solidFill>
+                          <a:latin typeface="Calibri"/>
+                        </a:rPr>
+                        <a:t>vs BP FY27 (EUR 2,296,577)</a:t>
+                      </a:r>
+                    </a:p>
+                  </a:txBody>
+                  <a:tcPr anchor="ctr" marL="73152" marR="73152">
+                    <a:solidFill>
+                      <a:srgbClr val="ECECEC"/>
+                    </a:solidFill>
+                  </a:tcPr>
+                </a:tc>
+                <a:tc>
+                  <a:txBody>
+                    <a:bodyPr/>
+                    <a:lstStyle/>
+                    <a:p>
+                      <a:pPr algn="r"/>
+                      <a:r>
+                        <a:rPr sz="1250" b="0">
+                          <a:solidFill>
+                            <a:srgbClr val="1A1A1A"/>
+                          </a:solidFill>
+                          <a:latin typeface="Calibri"/>
+                        </a:rPr>
+                        <a:t>+1.9%</a:t>
+                      </a:r>
+                    </a:p>
+                  </a:txBody>
+                  <a:tcPr anchor="ctr" marL="73152" marR="73152">
+                    <a:solidFill>
+                      <a:srgbClr val="ECECEC"/>
+                    </a:solidFill>
+                  </a:tcPr>
+                </a:tc>
+              </a:tr>
+              <a:tr h="354330">
                 <a:tc>
                   <a:txBody>
                     <a:bodyPr/>
@@ -7160,7 +7235,7 @@
                           </a:solidFill>
                           <a:latin typeface="Calibri"/>
                         </a:rPr>
-                        <a:t>vs FY2026 Sales-to-Dealer (EUR 6,834,272)</a:t>
+                        <a:t>Stretch included</a:t>
                       </a:r>
                     </a:p>
                   </a:txBody>
@@ -7183,7 +7258,7 @@
                           </a:solidFill>
                           <a:latin typeface="Calibri"/>
                         </a:rPr>
-                        <a:t>+3.5%</a:t>
+                        <a:t>+1.8%</a:t>
                       </a:r>
                     </a:p>
                   </a:txBody>
@@ -9929,9 +10004,87 @@
         <p:nvPr/>
       </p:nvGrpSpPr>
       <p:grpSpPr/>
+      <p:sp>
+        <p:nvSpPr>
+          <p:cNvPr id="2" name="Rectangle 1"/>
+          <p:cNvSpPr/>
+          <p:nvPr/>
+        </p:nvSpPr>
+        <p:spPr>
+          <a:xfrm>
+            <a:off x="0" y="0"/>
+            <a:ext cx="201168" cy="6858000"/>
+          </a:xfrm>
+          <a:prstGeom prst="rect">
+            <a:avLst/>
+          </a:prstGeom>
+          <a:solidFill>
+            <a:srgbClr val="CC0E1E"/>
+          </a:solidFill>
+          <a:ln>
+            <a:noFill/>
+          </a:ln>
+        </p:spPr>
+        <p:style>
+          <a:lnRef idx="1">
+            <a:schemeClr val="accent1"/>
+          </a:lnRef>
+          <a:fillRef idx="3">
+            <a:schemeClr val="accent1"/>
+          </a:fillRef>
+          <a:effectRef idx="2">
+            <a:schemeClr val="accent1"/>
+          </a:effectRef>
+          <a:fontRef idx="minor">
+            <a:schemeClr val="lt1"/>
+          </a:fontRef>
+        </p:style>
+        <p:txBody>
+          <a:bodyPr rtlCol="0" anchor="ctr"/>
+          <a:lstStyle/>
+          <a:p>
+            <a:pPr algn="ctr"/>
+          </a:p>
+        </p:txBody>
+      </p:sp>
+      <p:sp>
+        <p:nvSpPr>
+          <p:cNvPr id="3" name="TextBox 2"/>
+          <p:cNvSpPr txBox="1"/>
+          <p:nvPr/>
+        </p:nvSpPr>
+        <p:spPr>
+          <a:xfrm>
+            <a:off x="2286000" y="3063240"/>
+            <a:ext cx="7772400" cy="457200"/>
+          </a:xfrm>
+          <a:prstGeom prst="rect">
+            <a:avLst/>
+          </a:prstGeom>
+          <a:noFill/>
+        </p:spPr>
+        <p:txBody>
+          <a:bodyPr wrap="square">
+            <a:spAutoFit/>
+          </a:bodyPr>
+          <a:lstStyle/>
+          <a:p>
+            <a:pPr algn="ctr"/>
+            <a:r>
+              <a:rPr sz="1600" b="0">
+                <a:solidFill>
+                  <a:srgbClr val="5A5A5A"/>
+                </a:solidFill>
+                <a:latin typeface="Calibri"/>
+              </a:rPr>
+              <a:t>Moving the World – for You</a:t>
+            </a:r>
+          </a:p>
+        </p:txBody>
+      </p:sp>
       <p:pic>
         <p:nvPicPr>
-          <p:cNvPr id="2" name="Picture 1" descr="isuzu_logo_red.png"/>
+          <p:cNvPr id="4" name="Picture 3" descr="isuzu_logo_red.png"/>
           <p:cNvPicPr>
             <a:picLocks noChangeAspect="1"/>
           </p:cNvPicPr>
@@ -9945,396 +10098,14 @@
         </p:blipFill>
         <p:spPr>
           <a:xfrm>
-            <a:off x="256032" y="6263640"/>
-            <a:ext cx="1679787" cy="292608"/>
+            <a:off x="4631436" y="2468880"/>
+            <a:ext cx="2926080" cy="509704"/>
           </a:xfrm>
           <a:prstGeom prst="rect">
             <a:avLst/>
           </a:prstGeom>
         </p:spPr>
       </p:pic>
-      <p:sp>
-        <p:nvSpPr>
-          <p:cNvPr id="3" name="Rectangle 2"/>
-          <p:cNvSpPr/>
-          <p:nvPr/>
-        </p:nvSpPr>
-        <p:spPr>
-          <a:xfrm>
-            <a:off x="0" y="6766560"/>
-            <a:ext cx="12188952" cy="91440"/>
-          </a:xfrm>
-          <a:prstGeom prst="rect">
-            <a:avLst/>
-          </a:prstGeom>
-          <a:solidFill>
-            <a:srgbClr val="CC0E1E"/>
-          </a:solidFill>
-          <a:ln>
-            <a:noFill/>
-          </a:ln>
-        </p:spPr>
-        <p:style>
-          <a:lnRef idx="1">
-            <a:schemeClr val="accent1"/>
-          </a:lnRef>
-          <a:fillRef idx="3">
-            <a:schemeClr val="accent1"/>
-          </a:fillRef>
-          <a:effectRef idx="2">
-            <a:schemeClr val="accent1"/>
-          </a:effectRef>
-          <a:fontRef idx="minor">
-            <a:schemeClr val="lt1"/>
-          </a:fontRef>
-        </p:style>
-        <p:txBody>
-          <a:bodyPr rtlCol="0" anchor="ctr"/>
-          <a:lstStyle/>
-          <a:p>
-            <a:pPr algn="ctr"/>
-          </a:p>
-        </p:txBody>
-      </p:sp>
-      <p:sp>
-        <p:nvSpPr>
-          <p:cNvPr id="4" name="TextBox 3"/>
-          <p:cNvSpPr txBox="1"/>
-          <p:nvPr/>
-        </p:nvSpPr>
-        <p:spPr>
-          <a:xfrm>
-            <a:off x="292608" y="201168"/>
-            <a:ext cx="11430000" cy="274320"/>
-          </a:xfrm>
-          <a:prstGeom prst="rect">
-            <a:avLst/>
-          </a:prstGeom>
-          <a:noFill/>
-        </p:spPr>
-        <p:txBody>
-          <a:bodyPr wrap="square">
-            <a:spAutoFit/>
-          </a:bodyPr>
-          <a:lstStyle/>
-          <a:p>
-            <a:pPr algn="l"/>
-            <a:r>
-              <a:rPr sz="1100" b="1">
-                <a:solidFill>
-                  <a:srgbClr val="CC0E1E"/>
-                </a:solidFill>
-                <a:latin typeface="Calibri"/>
-              </a:rPr>
-              <a:t>SUMMARY</a:t>
-            </a:r>
-          </a:p>
-        </p:txBody>
-      </p:sp>
-      <p:sp>
-        <p:nvSpPr>
-          <p:cNvPr id="5" name="TextBox 4"/>
-          <p:cNvSpPr txBox="1"/>
-          <p:nvPr/>
-        </p:nvSpPr>
-        <p:spPr>
-          <a:xfrm>
-            <a:off x="292608" y="475488"/>
-            <a:ext cx="11612880" cy="566928"/>
-          </a:xfrm>
-          <a:prstGeom prst="rect">
-            <a:avLst/>
-          </a:prstGeom>
-          <a:noFill/>
-        </p:spPr>
-        <p:txBody>
-          <a:bodyPr wrap="square">
-            <a:spAutoFit/>
-          </a:bodyPr>
-          <a:lstStyle/>
-          <a:p>
-            <a:pPr algn="l"/>
-            <a:r>
-              <a:rPr sz="2500" b="1">
-                <a:solidFill>
-                  <a:srgbClr val="1A1A1A"/>
-                </a:solidFill>
-                <a:latin typeface="Calibri"/>
-              </a:rPr>
-              <a:t>Next steps</a:t>
-            </a:r>
-          </a:p>
-        </p:txBody>
-      </p:sp>
-      <p:sp>
-        <p:nvSpPr>
-          <p:cNvPr id="6" name="Rectangle 5"/>
-          <p:cNvSpPr/>
-          <p:nvPr/>
-        </p:nvSpPr>
-        <p:spPr>
-          <a:xfrm>
-            <a:off x="292608" y="1005840"/>
-            <a:ext cx="11612880" cy="28000"/>
-          </a:xfrm>
-          <a:prstGeom prst="rect">
-            <a:avLst/>
-          </a:prstGeom>
-          <a:solidFill>
-            <a:srgbClr val="CC0E1E"/>
-          </a:solidFill>
-          <a:ln>
-            <a:noFill/>
-          </a:ln>
-        </p:spPr>
-        <p:style>
-          <a:lnRef idx="1">
-            <a:schemeClr val="accent1"/>
-          </a:lnRef>
-          <a:fillRef idx="3">
-            <a:schemeClr val="accent1"/>
-          </a:fillRef>
-          <a:effectRef idx="2">
-            <a:schemeClr val="accent1"/>
-          </a:effectRef>
-          <a:fontRef idx="minor">
-            <a:schemeClr val="lt1"/>
-          </a:fontRef>
-        </p:style>
-        <p:txBody>
-          <a:bodyPr rtlCol="0" anchor="ctr"/>
-          <a:lstStyle/>
-          <a:p>
-            <a:pPr algn="ctr"/>
-          </a:p>
-        </p:txBody>
-      </p:sp>
-      <p:sp>
-        <p:nvSpPr>
-          <p:cNvPr id="7" name="TextBox 6"/>
-          <p:cNvSpPr txBox="1"/>
-          <p:nvPr/>
-        </p:nvSpPr>
-        <p:spPr>
-          <a:xfrm>
-            <a:off x="11594592" y="6473952"/>
-            <a:ext cx="365760" cy="274320"/>
-          </a:xfrm>
-          <a:prstGeom prst="rect">
-            <a:avLst/>
-          </a:prstGeom>
-          <a:noFill/>
-        </p:spPr>
-        <p:txBody>
-          <a:bodyPr wrap="square">
-            <a:spAutoFit/>
-          </a:bodyPr>
-          <a:lstStyle/>
-          <a:p>
-            <a:pPr algn="r"/>
-            <a:r>
-              <a:rPr sz="1000" b="0">
-                <a:solidFill>
-                  <a:srgbClr val="5A5A5A"/>
-                </a:solidFill>
-                <a:latin typeface="Calibri"/>
-              </a:rPr>
-              <a:t>19</a:t>
-            </a:r>
-          </a:p>
-        </p:txBody>
-      </p:sp>
-      <p:sp>
-        <p:nvSpPr>
-          <p:cNvPr id="8" name="TextBox 7"/>
-          <p:cNvSpPr txBox="1"/>
-          <p:nvPr/>
-        </p:nvSpPr>
-        <p:spPr>
-          <a:xfrm>
-            <a:off x="292608" y="1234440"/>
-            <a:ext cx="11612880" cy="4206240"/>
-          </a:xfrm>
-          <a:prstGeom prst="rect">
-            <a:avLst/>
-          </a:prstGeom>
-          <a:noFill/>
-        </p:spPr>
-        <p:txBody>
-          <a:bodyPr wrap="square">
-            <a:spAutoFit/>
-          </a:bodyPr>
-          <a:lstStyle/>
-          <a:p>
-            <a:pPr>
-              <a:lnSpc>
-                <a:spcPct val="125000"/>
-              </a:lnSpc>
-              <a:spcAft>
-                <a:spcPts val="1000"/>
-              </a:spcAft>
-            </a:pPr>
-            <a:r>
-              <a:rPr sz="1500" b="1">
-                <a:solidFill>
-                  <a:srgbClr val="CC0E1E"/>
-                </a:solidFill>
-                <a:latin typeface="Calibri"/>
-              </a:rPr>
-              <a:t>—  </a:t>
-            </a:r>
-            <a:r>
-              <a:rPr sz="1500">
-                <a:solidFill>
-                  <a:srgbClr val="1A1A1A"/>
-                </a:solidFill>
-                <a:latin typeface="Calibri"/>
-              </a:rPr>
-              <a:t>Confirm FY2027 Sales-to-Dealer target: EUR 7,074,416 (+3.5% vs FY2026 Sales-to-Dealer).</a:t>
-            </a:r>
-          </a:p>
-          <a:p>
-            <a:pPr>
-              <a:lnSpc>
-                <a:spcPct val="125000"/>
-              </a:lnSpc>
-              <a:spcAft>
-                <a:spcPts val="1000"/>
-              </a:spcAft>
-            </a:pPr>
-            <a:r>
-              <a:rPr sz="1500" b="1">
-                <a:solidFill>
-                  <a:srgbClr val="CC0E1E"/>
-                </a:solidFill>
-                <a:latin typeface="Calibri"/>
-              </a:rPr>
-              <a:t>—  </a:t>
-            </a:r>
-            <a:r>
-              <a:rPr sz="1500">
-                <a:solidFill>
-                  <a:srgbClr val="1A1A1A"/>
-                </a:solidFill>
-                <a:latin typeface="Calibri"/>
-              </a:rPr>
-              <a:t>Confirm the incentive alongside the price adjustment once approved on our side.</a:t>
-            </a:r>
-          </a:p>
-          <a:p>
-            <a:pPr>
-              <a:lnSpc>
-                <a:spcPct val="125000"/>
-              </a:lnSpc>
-              <a:spcAft>
-                <a:spcPts val="1000"/>
-              </a:spcAft>
-            </a:pPr>
-            <a:r>
-              <a:rPr sz="1500" b="1">
-                <a:solidFill>
-                  <a:srgbClr val="CC0E1E"/>
-                </a:solidFill>
-                <a:latin typeface="Calibri"/>
-              </a:rPr>
-              <a:t>—  </a:t>
-            </a:r>
-            <a:r>
-              <a:rPr sz="1500">
-                <a:solidFill>
-                  <a:srgbClr val="1A1A1A"/>
-                </a:solidFill>
-                <a:latin typeface="Calibri"/>
-              </a:rPr>
-              <a:t>Brake parts / Injectors / Fuel system: agree which category we tackle first, and what the joint action is.</a:t>
-            </a:r>
-          </a:p>
-          <a:p>
-            <a:pPr>
-              <a:lnSpc>
-                <a:spcPct val="125000"/>
-              </a:lnSpc>
-              <a:spcAft>
-                <a:spcPts val="1000"/>
-              </a:spcAft>
-            </a:pPr>
-            <a:r>
-              <a:rPr sz="1500" b="1">
-                <a:solidFill>
-                  <a:srgbClr val="CC0E1E"/>
-                </a:solidFill>
-                <a:latin typeface="Calibri"/>
-              </a:rPr>
-              <a:t>—  </a:t>
-            </a:r>
-            <a:r>
-              <a:rPr sz="1500">
-                <a:solidFill>
-                  <a:srgbClr val="1A1A1A"/>
-                </a:solidFill>
-                <a:latin typeface="Calibri"/>
-              </a:rPr>
-              <a:t>Agree part-level Sales-to-Dealer data sharing, effective 01/01/2025.</a:t>
-            </a:r>
-          </a:p>
-          <a:p>
-            <a:pPr>
-              <a:lnSpc>
-                <a:spcPct val="125000"/>
-              </a:lnSpc>
-              <a:spcAft>
-                <a:spcPts val="1000"/>
-              </a:spcAft>
-            </a:pPr>
-            <a:r>
-              <a:rPr sz="1500" b="1">
-                <a:solidFill>
-                  <a:srgbClr val="CC0E1E"/>
-                </a:solidFill>
-                <a:latin typeface="Calibri"/>
-              </a:rPr>
-              <a:t>—  </a:t>
-            </a:r>
-            <a:r>
-              <a:rPr sz="1500">
-                <a:solidFill>
-                  <a:srgbClr val="1A1A1A"/>
-                </a:solidFill>
-                <a:latin typeface="Calibri"/>
-              </a:rPr>
-              <a:t>SPA: IBX proposal, ISZE review and counter-proposal cycle to follow.</a:t>
-            </a:r>
-          </a:p>
-          <a:p>
-            <a:pPr>
-              <a:lnSpc>
-                <a:spcPct val="125000"/>
-              </a:lnSpc>
-              <a:spcAft>
-                <a:spcPts val="1000"/>
-              </a:spcAft>
-            </a:pPr>
-            <a:r>
-              <a:rPr sz="1500" b="1">
-                <a:solidFill>
-                  <a:srgbClr val="CC0E1E"/>
-                </a:solidFill>
-                <a:latin typeface="Calibri"/>
-              </a:rPr>
-              <a:t>—  </a:t>
-            </a:r>
-            <a:r>
-              <a:rPr sz="1500">
-                <a:solidFill>
-                  <a:srgbClr val="1A1A1A"/>
-                </a:solidFill>
-                <a:latin typeface="Calibri"/>
-              </a:rPr>
-              <a:t>IDS 2026: agree dealer visit dates, starting with the lower-scoring dealers.</a:t>
-            </a:r>
-          </a:p>
-        </p:txBody>
-      </p:sp>
     </p:spTree>
   </p:cSld>
   <p:clrMapOvr>
@@ -10622,7 +10393,7 @@
                 </a:solidFill>
                 <a:latin typeface="Calibri"/>
               </a:rPr>
-              <a:t>Parts Performance — category movers</a:t>
+              <a:t>FY2027 YTD (Apr–Jul) Sales Review</a:t>
             </a:r>
           </a:p>
           <a:p>
@@ -10650,7 +10421,7 @@
                 </a:solidFill>
                 <a:latin typeface="Calibri"/>
               </a:rPr>
-              <a:t>Parts Performance — Brake parts</a:t>
+              <a:t>Parts Performance — category movers</a:t>
             </a:r>
           </a:p>
           <a:p>
@@ -10678,7 +10449,7 @@
                 </a:solidFill>
                 <a:latin typeface="Calibri"/>
               </a:rPr>
-              <a:t>Parts Performance — Injectors</a:t>
+              <a:t>Parts Performance — Brake parts</a:t>
             </a:r>
           </a:p>
           <a:p>
@@ -10706,7 +10477,7 @@
                 </a:solidFill>
                 <a:latin typeface="Calibri"/>
               </a:rPr>
-              <a:t>Parts Performance — Fuel system</a:t>
+              <a:t>Parts Performance — Injectors</a:t>
             </a:r>
           </a:p>
           <a:p>
@@ -10734,7 +10505,7 @@
                 </a:solidFill>
                 <a:latin typeface="Calibri"/>
               </a:rPr>
-              <a:t>Parts Performance — where volume grew</a:t>
+              <a:t>Parts Performance — Fuel system</a:t>
             </a:r>
           </a:p>
           <a:p>
@@ -10762,7 +10533,7 @@
                 </a:solidFill>
                 <a:latin typeface="Calibri"/>
               </a:rPr>
-              <a:t>New Business — validation queue</a:t>
+              <a:t>Parts Performance — Body parts</a:t>
             </a:r>
           </a:p>
           <a:p>
@@ -10790,7 +10561,7 @@
                 </a:solidFill>
                 <a:latin typeface="Calibri"/>
               </a:rPr>
-              <a:t>Sales-to-Dealer Outlook</a:t>
+              <a:t>Parts Performance — where volume grew</a:t>
             </a:r>
           </a:p>
           <a:p>
@@ -10989,164 +10760,8 @@
               <a:t>Data request: part-level Sales-to-Dealer</a:t>
             </a:r>
           </a:p>
-          <a:p>
-            <a:pPr>
-              <a:lnSpc>
-                <a:spcPct val="110000"/>
-              </a:lnSpc>
-              <a:spcAft>
-                <a:spcPts val="1000"/>
-              </a:spcAft>
-            </a:pPr>
-            <a:r>
-              <a:rPr sz="1300" b="1">
-                <a:solidFill>
-                  <a:srgbClr val="CC0E1E"/>
-                </a:solidFill>
-                <a:latin typeface="Calibri"/>
-              </a:rPr>
-              <a:t>—  </a:t>
-            </a:r>
-            <a:r>
-              <a:rPr sz="1300">
-                <a:solidFill>
-                  <a:srgbClr val="1A1A1A"/>
-                </a:solidFill>
-                <a:latin typeface="Calibri"/>
-              </a:rPr>
-              <a:t>Next steps</a:t>
-            </a:r>
-          </a:p>
-        </p:txBody>
-      </p:sp>
-    </p:spTree>
-  </p:cSld>
-  <p:clrMapOvr>
-    <a:masterClrMapping/>
-  </p:clrMapOvr>
-</p:sld>
-</file>
-
-<file path=ppt/slides/slide20.xml><?xml version="1.0" encoding="utf-8"?>
-<p:sld xmlns:a="http://schemas.openxmlformats.org/drawingml/2006/main" xmlns:p="http://schemas.openxmlformats.org/presentationml/2006/main" xmlns:r="http://schemas.openxmlformats.org/officeDocument/2006/relationships">
-  <p:cSld>
-    <p:bg>
-      <p:bgPr>
-        <a:solidFill>
-          <a:srgbClr val="FFFFFF"/>
-        </a:solidFill>
-        <a:effectLst/>
-      </p:bgPr>
-    </p:bg>
-    <p:spTree>
-      <p:nvGrpSpPr>
-        <p:cNvPr id="1" name=""/>
-        <p:cNvGrpSpPr/>
-        <p:nvPr/>
-      </p:nvGrpSpPr>
-      <p:grpSpPr/>
-      <p:sp>
-        <p:nvSpPr>
-          <p:cNvPr id="2" name="Rectangle 1"/>
-          <p:cNvSpPr/>
-          <p:nvPr/>
-        </p:nvSpPr>
-        <p:spPr>
-          <a:xfrm>
-            <a:off x="0" y="0"/>
-            <a:ext cx="201168" cy="6858000"/>
-          </a:xfrm>
-          <a:prstGeom prst="rect">
-            <a:avLst/>
-          </a:prstGeom>
-          <a:solidFill>
-            <a:srgbClr val="CC0E1E"/>
-          </a:solidFill>
-          <a:ln>
-            <a:noFill/>
-          </a:ln>
-        </p:spPr>
-        <p:style>
-          <a:lnRef idx="1">
-            <a:schemeClr val="accent1"/>
-          </a:lnRef>
-          <a:fillRef idx="3">
-            <a:schemeClr val="accent1"/>
-          </a:fillRef>
-          <a:effectRef idx="2">
-            <a:schemeClr val="accent1"/>
-          </a:effectRef>
-          <a:fontRef idx="minor">
-            <a:schemeClr val="lt1"/>
-          </a:fontRef>
-        </p:style>
-        <p:txBody>
-          <a:bodyPr rtlCol="0" anchor="ctr"/>
-          <a:lstStyle/>
-          <a:p>
-            <a:pPr algn="ctr"/>
-          </a:p>
-        </p:txBody>
-      </p:sp>
-      <p:sp>
-        <p:nvSpPr>
-          <p:cNvPr id="3" name="TextBox 2"/>
-          <p:cNvSpPr txBox="1"/>
-          <p:nvPr/>
-        </p:nvSpPr>
-        <p:spPr>
-          <a:xfrm>
-            <a:off x="2286000" y="3063240"/>
-            <a:ext cx="7772400" cy="457200"/>
-          </a:xfrm>
-          <a:prstGeom prst="rect">
-            <a:avLst/>
-          </a:prstGeom>
-          <a:noFill/>
-        </p:spPr>
-        <p:txBody>
-          <a:bodyPr wrap="square">
-            <a:spAutoFit/>
-          </a:bodyPr>
-          <a:lstStyle/>
-          <a:p>
-            <a:pPr algn="ctr"/>
-            <a:r>
-              <a:rPr sz="1600" b="0">
-                <a:solidFill>
-                  <a:srgbClr val="5A5A5A"/>
-                </a:solidFill>
-                <a:latin typeface="Calibri"/>
-              </a:rPr>
-              <a:t>Moving the World – for You</a:t>
-            </a:r>
-          </a:p>
-        </p:txBody>
-      </p:sp>
-      <p:pic>
-        <p:nvPicPr>
-          <p:cNvPr id="4" name="Picture 3" descr="isuzu_logo_red.png"/>
-          <p:cNvPicPr>
-            <a:picLocks noChangeAspect="1"/>
-          </p:cNvPicPr>
-          <p:nvPr/>
-        </p:nvPicPr>
-        <p:blipFill>
-          <a:blip r:embed="rId2"/>
-          <a:stretch>
-            <a:fillRect/>
-          </a:stretch>
-        </p:blipFill>
-        <p:spPr>
-          <a:xfrm>
-            <a:off x="4631436" y="2468880"/>
-            <a:ext cx="2926080" cy="509704"/>
-          </a:xfrm>
-          <a:prstGeom prst="rect">
-            <a:avLst/>
-          </a:prstGeom>
-        </p:spPr>
-      </p:pic>
+        </p:txBody>
+      </p:sp>
     </p:spTree>
   </p:cSld>
   <p:clrMapOvr>
@@ -11270,7 +10885,7 @@
                 </a:solidFill>
                 <a:latin typeface="Calibri"/>
               </a:rPr>
-              <a:t>PARTS PERFORMANCE</a:t>
+              <a:t>POWER BI — OFFICIAL CUT</a:t>
             </a:r>
           </a:p>
         </p:txBody>
@@ -11305,7 +10920,7 @@
                 </a:solidFill>
                 <a:latin typeface="Calibri"/>
               </a:rPr>
-              <a:t>Parts Performance — CY H1 2026 vs CY H1 2025 (commercial, ex-warranty)</a:t>
+              <a:t>FY2027 YTD (Apr–Jul): EUR 726K, +1% vs budget</a:t>
             </a:r>
           </a:p>
         </p:txBody>
@@ -11390,7 +11005,7 @@
       </p:sp>
       <p:pic>
         <p:nvPicPr>
-          <p:cNvPr id="8" name="Picture 7" descr="category_movers.png"/>
+          <p:cNvPr id="8" name="Picture 7" descr="quarter.png"/>
           <p:cNvPicPr>
             <a:picLocks noChangeAspect="1"/>
           </p:cNvPicPr>
@@ -11404,8 +11019,8 @@
         </p:blipFill>
         <p:spPr>
           <a:xfrm>
-            <a:off x="292608" y="2120980"/>
-            <a:ext cx="7178040" cy="3027520"/>
+            <a:off x="292608" y="2050572"/>
+            <a:ext cx="7178040" cy="3168335"/>
           </a:xfrm>
           <a:prstGeom prst="rect">
             <a:avLst/>
@@ -11536,7 +11151,7 @@
                 </a:solidFill>
                 <a:latin typeface="Calibri"/>
               </a:rPr>
-              <a:t>Commercial parts billing (warranty/campaign excluded) EUR 1,029K against EUR 828K a year earlier — +24.3% (CY H1 2026 vs CY H1 2025, Jan–Jun).</a:t>
+              <a:t>Sales EUR 726K against a EUR 717K budget — +1%, and +22% on last year's EUR 595K.</a:t>
             </a:r>
           </a:p>
           <a:p>
@@ -11564,7 +11179,7 @@
                 </a:solidFill>
                 <a:latin typeface="Calibri"/>
               </a:rPr>
-              <a:t>Largest PN drops (all categories): 5878316930 (SHOE KIT; BRAKE,RR) EUR -13K, 62 fewer pcs; 8974725274 (RAIL; ROOF) EUR -4K, 34 fewer pcs; 8977988670 (TRANSFER ASM) EUR -4K, 2 fewer pcs.</a:t>
+              <a:t>Order intake EUR 631K against EUR 726K billed (orders ~87% of shipments).</a:t>
             </a:r>
           </a:p>
           <a:p>
@@ -11592,7 +11207,7 @@
                 </a:solidFill>
                 <a:latin typeface="Calibri"/>
               </a:rPr>
-              <a:t>Largest PN gains (all categories): 8978461152 (GLASS; WINDSHIELD) EUR 18K, 79 more pcs; 8981776324 (DPD ASM) EUR 8K, 6 more pcs; 8975554500 (FILTER; BLOWER UNIT) [TF*,UC*] EUR 7K, 407 more pcs.</a:t>
+              <a:t>By month vs budget: Apr +1%, May +1%, Jun +1%, Jul +2%.</a:t>
             </a:r>
           </a:p>
           <a:p>
@@ -11620,7 +11235,7 @@
                 </a:solidFill>
                 <a:latin typeface="Calibri"/>
               </a:rPr>
-              <a:t>Within Body parts (EUR 102K, +36%): 8978461152 (GLASS; WINDSHIELD) EUR 18K, 79 more pcs; 8975595830 (PANEL; SIDE GATE) EUR 4K, 19 more pcs; 7552172691 (BUMPER ASM; FRT) EUR 4K, 26 more pcs.</a:t>
+              <a:t>Jul softened (-48% YoY) — holiday timing / stock build can explain a quiet month after a strong spring.</a:t>
             </a:r>
           </a:p>
         </p:txBody>
@@ -11748,7 +11363,7 @@
                 </a:solidFill>
                 <a:latin typeface="Calibri"/>
               </a:rPr>
-              <a:t>PARTS PERFORMANCE — BRAKE PARTS</a:t>
+              <a:t>PARTS PERFORMANCE</a:t>
             </a:r>
           </a:p>
         </p:txBody>
@@ -11783,7 +11398,7 @@
                 </a:solidFill>
                 <a:latin typeface="Calibri"/>
               </a:rPr>
-              <a:t>Brake parts — CY H1 2026 vs CY H1 2025 (commercial, ex-warranty)</a:t>
+              <a:t>Parts Performance — CY H1 2026 vs CY H1 2025 (commercial, ex-warranty)</a:t>
             </a:r>
           </a:p>
         </p:txBody>
@@ -11866,16 +11481,118 @@
           </a:p>
         </p:txBody>
       </p:sp>
-      <p:sp>
-        <p:nvSpPr>
-          <p:cNvPr id="8" name="TextBox 7"/>
+      <p:pic>
+        <p:nvPicPr>
+          <p:cNvPr id="8" name="Picture 7" descr="category_movers.png"/>
+          <p:cNvPicPr>
+            <a:picLocks noChangeAspect="1"/>
+          </p:cNvPicPr>
+          <p:nvPr/>
+        </p:nvPicPr>
+        <p:blipFill>
+          <a:blip r:embed="rId3"/>
+          <a:stretch>
+            <a:fillRect/>
+          </a:stretch>
+        </p:blipFill>
+        <p:spPr>
+          <a:xfrm>
+            <a:off x="292608" y="2120980"/>
+            <a:ext cx="7178040" cy="3027520"/>
+          </a:xfrm>
+          <a:prstGeom prst="rect">
+            <a:avLst/>
+          </a:prstGeom>
+        </p:spPr>
+      </p:pic>
+      <p:sp>
+        <p:nvSpPr>
+          <p:cNvPr id="9" name="Rectangle 8"/>
+          <p:cNvSpPr/>
+          <p:nvPr/>
+        </p:nvSpPr>
+        <p:spPr>
+          <a:xfrm>
+            <a:off x="7726679" y="1188720"/>
+            <a:ext cx="22000" cy="4892040"/>
+          </a:xfrm>
+          <a:prstGeom prst="rect">
+            <a:avLst/>
+          </a:prstGeom>
+          <a:solidFill>
+            <a:srgbClr val="ECECEC"/>
+          </a:solidFill>
+          <a:ln>
+            <a:noFill/>
+          </a:ln>
+        </p:spPr>
+        <p:style>
+          <a:lnRef idx="1">
+            <a:schemeClr val="accent1"/>
+          </a:lnRef>
+          <a:fillRef idx="3">
+            <a:schemeClr val="accent1"/>
+          </a:fillRef>
+          <a:effectRef idx="2">
+            <a:schemeClr val="accent1"/>
+          </a:effectRef>
+          <a:fontRef idx="minor">
+            <a:schemeClr val="lt1"/>
+          </a:fontRef>
+        </p:style>
+        <p:txBody>
+          <a:bodyPr rtlCol="0" anchor="ctr"/>
+          <a:lstStyle/>
+          <a:p>
+            <a:pPr algn="ctr"/>
+          </a:p>
+        </p:txBody>
+      </p:sp>
+      <p:sp>
+        <p:nvSpPr>
+          <p:cNvPr id="10" name="TextBox 9"/>
           <p:cNvSpPr txBox="1"/>
           <p:nvPr/>
         </p:nvSpPr>
         <p:spPr>
           <a:xfrm>
-            <a:off x="292608" y="1207008"/>
-            <a:ext cx="11612880" cy="2651760"/>
+            <a:off x="7927847" y="1234440"/>
+            <a:ext cx="3886200" cy="320040"/>
+          </a:xfrm>
+          <a:prstGeom prst="rect">
+            <a:avLst/>
+          </a:prstGeom>
+          <a:noFill/>
+        </p:spPr>
+        <p:txBody>
+          <a:bodyPr wrap="square">
+            <a:spAutoFit/>
+          </a:bodyPr>
+          <a:lstStyle/>
+          <a:p>
+            <a:pPr algn="l"/>
+            <a:r>
+              <a:rPr sz="1200" b="1">
+                <a:solidFill>
+                  <a:srgbClr val="CC0E1E"/>
+                </a:solidFill>
+                <a:latin typeface="Calibri"/>
+              </a:rPr>
+              <a:t>TAKEAWAYS</a:t>
+            </a:r>
+          </a:p>
+        </p:txBody>
+      </p:sp>
+      <p:sp>
+        <p:nvSpPr>
+          <p:cNvPr id="11" name="TextBox 10"/>
+          <p:cNvSpPr txBox="1"/>
+          <p:nvPr/>
+        </p:nvSpPr>
+        <p:spPr>
+          <a:xfrm>
+            <a:off x="7927847" y="1691640"/>
+            <a:ext cx="3794760" cy="4343400"/>
           </a:xfrm>
           <a:prstGeom prst="rect">
             <a:avLst/>
@@ -11897,7 +11614,7 @@
               </a:spcAft>
             </a:pPr>
             <a:r>
-              <a:rPr sz="1300" b="1">
+              <a:rPr sz="1250" b="1">
                 <a:solidFill>
                   <a:srgbClr val="CC0E1E"/>
                 </a:solidFill>
@@ -11906,13 +11623,13 @@
               <a:t>—  </a:t>
             </a:r>
             <a:r>
-              <a:rPr sz="1300">
+              <a:rPr sz="1250">
                 <a:solidFill>
                   <a:srgbClr val="1A1A1A"/>
                 </a:solidFill>
                 <a:latin typeface="Calibri"/>
               </a:rPr>
-              <a:t>EUR 42,206 (CY H1 2025) to EUR 29,058 (CY H1 2026), down EUR 13,148 (-31%).</a:t>
+              <a:t>Commercial parts billing (warranty/campaign excluded) EUR 1,029K against EUR 828K a year earlier — +24.3% (CY H1 2026 vs CY H1 2025, Jan–Jun).</a:t>
             </a:r>
           </a:p>
           <a:p>
@@ -11925,7 +11642,7 @@
               </a:spcAft>
             </a:pPr>
             <a:r>
-              <a:rPr sz="1300" b="1">
+              <a:rPr sz="1250" b="1">
                 <a:solidFill>
                   <a:srgbClr val="CC0E1E"/>
                 </a:solidFill>
@@ -11934,13 +11651,13 @@
               <a:t>—  </a:t>
             </a:r>
             <a:r>
-              <a:rPr sz="1300">
+              <a:rPr sz="1250">
                 <a:solidFill>
                   <a:srgbClr val="1A1A1A"/>
                 </a:solidFill>
                 <a:latin typeface="Calibri"/>
               </a:rPr>
-              <a:t>Largest part numbers driving the decline (by EUR):</a:t>
+              <a:t>Body parts EUR 102K (+36%) is excluded from the chart scale — covered on the Body deep-dive slide.</a:t>
             </a:r>
           </a:p>
           <a:p>
@@ -11953,7 +11670,7 @@
               </a:spcAft>
             </a:pPr>
             <a:r>
-              <a:rPr sz="1300" b="1">
+              <a:rPr sz="1250" b="1">
                 <a:solidFill>
                   <a:srgbClr val="CC0E1E"/>
                 </a:solidFill>
@@ -11962,13 +11679,13 @@
               <a:t>—  </a:t>
             </a:r>
             <a:r>
-              <a:rPr sz="1300">
+              <a:rPr sz="1250">
                 <a:solidFill>
                   <a:srgbClr val="1A1A1A"/>
                 </a:solidFill>
                 <a:latin typeface="Calibri"/>
               </a:rPr>
-              <a:t>5878316930 (SHOE KIT; BRAKE,RR): EUR 12,755 to EUR 0, 62 fewer pieces.</a:t>
+              <a:t>Largest PN drops (all categories): 5878316930 (SHOE KIT; BRAKE,RR) EUR -13K, 62 fewer pcs; 8974725274 (RAIL; ROOF) EUR -4K, 34 fewer pcs; 8977988670 (TRANSFER ASM) EUR -4K, 2 fewer pcs.</a:t>
             </a:r>
           </a:p>
           <a:p>
@@ -11981,7 +11698,7 @@
               </a:spcAft>
             </a:pPr>
             <a:r>
-              <a:rPr sz="1300" b="1">
+              <a:rPr sz="1250" b="1">
                 <a:solidFill>
                   <a:srgbClr val="CC0E1E"/>
                 </a:solidFill>
@@ -11990,211 +11707,13 @@
               <a:t>—  </a:t>
             </a:r>
             <a:r>
-              <a:rPr sz="1300">
+              <a:rPr sz="1250">
                 <a:solidFill>
                   <a:srgbClr val="1A1A1A"/>
                 </a:solidFill>
                 <a:latin typeface="Calibri"/>
               </a:rPr>
-              <a:t>5876102280 (LINING KIT; RR BRAKE · NPR,NQR,NNR): EUR 3,276 to EUR 0, 57 fewer pieces.</a:t>
-            </a:r>
-          </a:p>
-          <a:p>
-            <a:pPr>
-              <a:lnSpc>
-                <a:spcPct val="125000"/>
-              </a:lnSpc>
-              <a:spcAft>
-                <a:spcPts val="1000"/>
-              </a:spcAft>
-            </a:pPr>
-            <a:r>
-              <a:rPr sz="1300" b="1">
-                <a:solidFill>
-                  <a:srgbClr val="CC0E1E"/>
-                </a:solidFill>
-                <a:latin typeface="Calibri"/>
-              </a:rPr>
-              <a:t>—  </a:t>
-            </a:r>
-            <a:r>
-              <a:rPr sz="1300">
-                <a:solidFill>
-                  <a:srgbClr val="1A1A1A"/>
-                </a:solidFill>
-                <a:latin typeface="Calibri"/>
-              </a:rPr>
-              <a:t>8981246634 (ROTOR; DISC BRK,FRT): EUR 1,335 to EUR 375, 11 fewer pieces.</a:t>
-            </a:r>
-          </a:p>
-          <a:p>
-            <a:pPr>
-              <a:lnSpc>
-                <a:spcPct val="125000"/>
-              </a:lnSpc>
-              <a:spcAft>
-                <a:spcPts val="1000"/>
-              </a:spcAft>
-            </a:pPr>
-            <a:r>
-              <a:rPr sz="1300" b="1">
-                <a:solidFill>
-                  <a:srgbClr val="CC0E1E"/>
-                </a:solidFill>
-                <a:latin typeface="Calibri"/>
-              </a:rPr>
-              <a:t>—  </a:t>
-            </a:r>
-            <a:r>
-              <a:rPr sz="1300">
-                <a:solidFill>
-                  <a:srgbClr val="1A1A1A"/>
-                </a:solidFill>
-                <a:latin typeface="Calibri"/>
-              </a:rPr>
-              <a:t>8982324811 (HYDRAULIC UNIT; ANTI LOCK BRK): EUR 858 to EUR 0, 1 fewer pieces.</a:t>
-            </a:r>
-          </a:p>
-        </p:txBody>
-      </p:sp>
-      <p:sp>
-        <p:nvSpPr>
-          <p:cNvPr id="9" name="TextBox 8"/>
-          <p:cNvSpPr txBox="1"/>
-          <p:nvPr/>
-        </p:nvSpPr>
-        <p:spPr>
-          <a:xfrm>
-            <a:off x="292608" y="3840480"/>
-            <a:ext cx="8595360" cy="274320"/>
-          </a:xfrm>
-          <a:prstGeom prst="rect">
-            <a:avLst/>
-          </a:prstGeom>
-          <a:noFill/>
-        </p:spPr>
-        <p:txBody>
-          <a:bodyPr wrap="square">
-            <a:spAutoFit/>
-          </a:bodyPr>
-          <a:lstStyle/>
-          <a:p>
-            <a:pPr algn="l"/>
-            <a:r>
-              <a:rPr sz="1300" b="1">
-                <a:solidFill>
-                  <a:srgbClr val="CC0E1E"/>
-                </a:solidFill>
-                <a:latin typeface="Calibri"/>
-              </a:rPr>
-              <a:t>Questions for us to work through together</a:t>
-            </a:r>
-          </a:p>
-        </p:txBody>
-      </p:sp>
-      <p:sp>
-        <p:nvSpPr>
-          <p:cNvPr id="10" name="TextBox 9"/>
-          <p:cNvSpPr txBox="1"/>
-          <p:nvPr/>
-        </p:nvSpPr>
-        <p:spPr>
-          <a:xfrm>
-            <a:off x="292608" y="4160520"/>
-            <a:ext cx="11612880" cy="1737360"/>
-          </a:xfrm>
-          <a:prstGeom prst="rect">
-            <a:avLst/>
-          </a:prstGeom>
-          <a:noFill/>
-        </p:spPr>
-        <p:txBody>
-          <a:bodyPr wrap="square">
-            <a:spAutoFit/>
-          </a:bodyPr>
-          <a:lstStyle/>
-          <a:p>
-            <a:pPr>
-              <a:lnSpc>
-                <a:spcPct val="125000"/>
-              </a:lnSpc>
-              <a:spcAft>
-                <a:spcPts val="1000"/>
-              </a:spcAft>
-            </a:pPr>
-            <a:r>
-              <a:rPr sz="1400" b="1">
-                <a:solidFill>
-                  <a:srgbClr val="CC0E1E"/>
-                </a:solidFill>
-                <a:latin typeface="Calibri"/>
-              </a:rPr>
-              <a:t>—  </a:t>
-            </a:r>
-            <a:r>
-              <a:rPr sz="1400">
-                <a:solidFill>
-                  <a:srgbClr val="1A1A1A"/>
-                </a:solidFill>
-                <a:latin typeface="Calibri"/>
-              </a:rPr>
-              <a:t>Is pad and rotor pricing competitive against what the dealers can buy locally?</a:t>
-            </a:r>
-          </a:p>
-          <a:p>
-            <a:pPr>
-              <a:lnSpc>
-                <a:spcPct val="125000"/>
-              </a:lnSpc>
-              <a:spcAft>
-                <a:spcPts val="1000"/>
-              </a:spcAft>
-            </a:pPr>
-            <a:r>
-              <a:rPr sz="1400" b="1">
-                <a:solidFill>
-                  <a:srgbClr val="CC0E1E"/>
-                </a:solidFill>
-                <a:latin typeface="Calibri"/>
-              </a:rPr>
-              <a:t>—  </a:t>
-            </a:r>
-            <a:r>
-              <a:rPr sz="1400">
-                <a:solidFill>
-                  <a:srgbClr val="1A1A1A"/>
-                </a:solidFill>
-                <a:latin typeface="Calibri"/>
-              </a:rPr>
-              <a:t>Is any of this stock timing on your side rather than end demand?</a:t>
-            </a:r>
-          </a:p>
-          <a:p>
-            <a:pPr>
-              <a:lnSpc>
-                <a:spcPct val="125000"/>
-              </a:lnSpc>
-              <a:spcAft>
-                <a:spcPts val="1000"/>
-              </a:spcAft>
-            </a:pPr>
-            <a:r>
-              <a:rPr sz="1400" b="1">
-                <a:solidFill>
-                  <a:srgbClr val="CC0E1E"/>
-                </a:solidFill>
-                <a:latin typeface="Calibri"/>
-              </a:rPr>
-              <a:t>—  </a:t>
-            </a:r>
-            <a:r>
-              <a:rPr sz="1400">
-                <a:solidFill>
-                  <a:srgbClr val="1A1A1A"/>
-                </a:solidFill>
-                <a:latin typeface="Calibri"/>
-              </a:rPr>
-              <a:t>Are dealers still quoting these part numbers, or have they dropped off the workshop menu?</a:t>
+              <a:t>Largest PN gains (all categories): 8978461152 (GLASS; WINDSHIELD) EUR 18K, 79 more pcs; 8981776324 (DPD ASM) EUR 8K, 6 more pcs; 8975554500 (FILTER; BLOWER UNIT) [TF*,UC*] EUR 7K, 407 more pcs.</a:t>
             </a:r>
           </a:p>
         </p:txBody>
@@ -12322,7 +11841,7 @@
                 </a:solidFill>
                 <a:latin typeface="Calibri"/>
               </a:rPr>
-              <a:t>PARTS PERFORMANCE — INJECTORS</a:t>
+              <a:t>PARTS PERFORMANCE — BRAKE PARTS</a:t>
             </a:r>
           </a:p>
         </p:txBody>
@@ -12357,7 +11876,7 @@
                 </a:solidFill>
                 <a:latin typeface="Calibri"/>
               </a:rPr>
-              <a:t>Injectors — CY H1 2026 vs CY H1 2025 (commercial, ex-warranty)</a:t>
+              <a:t>Brake parts — CY H1 2026 vs CY H1 2025 (commercial, ex-warranty)</a:t>
             </a:r>
           </a:p>
         </p:txBody>
@@ -12486,7 +12005,7 @@
                 </a:solidFill>
                 <a:latin typeface="Calibri"/>
               </a:rPr>
-              <a:t>EUR 10,591 (CY H1 2025) to EUR 5,795 (CY H1 2026), down EUR 4,796 (-45%).</a:t>
+              <a:t>EUR 42,206 (CY H1 2025) to EUR 29,058 (CY H1 2026), down EUR 13,148 (-31%).</a:t>
             </a:r>
           </a:p>
           <a:p>
@@ -12542,7 +12061,7 @@
                 </a:solidFill>
                 <a:latin typeface="Calibri"/>
               </a:rPr>
-              <a:t>8984890190 (NOZZLE ASM; INJ): EUR 3,865 to EUR 1,887, 12 fewer pieces.</a:t>
+              <a:t>5878316930 (SHOE KIT; BRAKE,RR): EUR 12,755 to EUR 0, 62 fewer pieces.</a:t>
             </a:r>
           </a:p>
           <a:p>
@@ -12570,7 +12089,7 @@
                 </a:solidFill>
                 <a:latin typeface="Calibri"/>
               </a:rPr>
-              <a:t>8983320591 (NOZZLE ASM; INJ): EUR 1,321 to EUR 0, 7 fewer pieces.</a:t>
+              <a:t>5876102280 (LINING KIT; RR BRAKE · NPR,NQR,NNR): EUR 3,276 to EUR 0, 57 fewer pieces.</a:t>
             </a:r>
           </a:p>
           <a:p>
@@ -12598,7 +12117,7 @@
                 </a:solidFill>
                 <a:latin typeface="Calibri"/>
               </a:rPr>
-              <a:t>8973865576 (PUMP ASM; INJ): EUR 886 to EUR 0, 1 fewer pieces.</a:t>
+              <a:t>8981246634 (ROTOR; DISC BRK,FRT): EUR 1,335 to EUR 375, 11 fewer pieces.</a:t>
             </a:r>
           </a:p>
           <a:p>
@@ -12626,7 +12145,7 @@
                 </a:solidFill>
                 <a:latin typeface="Calibri"/>
               </a:rPr>
-              <a:t>8982601090 (NOZZLE ASM; INJ): EUR 2,710 to EUR 1,909, 6 fewer pieces.</a:t>
+              <a:t>8982324811 (HYDRAULIC UNIT; ANTI LOCK BRK): EUR 858 to EUR 0, 1 fewer pieces.</a:t>
             </a:r>
           </a:p>
         </p:txBody>
@@ -12712,7 +12231,7 @@
                 </a:solidFill>
                 <a:latin typeface="Calibri"/>
               </a:rPr>
-              <a:t>Is this fewer failures, or repairs moving out of the network?</a:t>
+              <a:t>Is pad and rotor pricing competitive against what the dealers can buy locally?</a:t>
             </a:r>
           </a:p>
           <a:p>
@@ -12740,7 +12259,7 @@
                 </a:solidFill>
                 <a:latin typeface="Calibri"/>
               </a:rPr>
-              <a:t>Is the exchange/reman route competing with new parts here?</a:t>
+              <a:t>Is any of this stock timing on your side rather than end demand?</a:t>
             </a:r>
           </a:p>
           <a:p>
@@ -12896,7 +12415,7 @@
                 </a:solidFill>
                 <a:latin typeface="Calibri"/>
               </a:rPr>
-              <a:t>PARTS PERFORMANCE — FUEL SYSTEM</a:t>
+              <a:t>PARTS PERFORMANCE — INJECTORS</a:t>
             </a:r>
           </a:p>
         </p:txBody>
@@ -12931,7 +12450,7 @@
                 </a:solidFill>
                 <a:latin typeface="Calibri"/>
               </a:rPr>
-              <a:t>Fuel system — CY H1 2026 vs CY H1 2025 (commercial, ex-warranty)</a:t>
+              <a:t>Injectors — CY H1 2026 vs CY H1 2025 (commercial, ex-warranty)</a:t>
             </a:r>
           </a:p>
         </p:txBody>
@@ -13060,7 +12579,7 @@
                 </a:solidFill>
                 <a:latin typeface="Calibri"/>
               </a:rPr>
-              <a:t>EUR 9,894 (CY H1 2025) to EUR 5,548 (CY H1 2026), down EUR 4,346 (-44%).</a:t>
+              <a:t>EUR 10,591 (CY H1 2025) to EUR 5,795 (CY H1 2026), down EUR 4,796 (-45%).</a:t>
             </a:r>
           </a:p>
           <a:p>
@@ -13116,7 +12635,7 @@
                 </a:solidFill>
                 <a:latin typeface="Calibri"/>
               </a:rPr>
-              <a:t>8941449334 (SEDIMENTER; FUEL): EUR 2,530 to EUR 0, 51 fewer pieces.</a:t>
+              <a:t>8984890190 (NOZZLE ASM; INJ): EUR 3,865 to EUR 1,887, 12 fewer pieces.</a:t>
             </a:r>
           </a:p>
           <a:p>
@@ -13144,7 +12663,7 @@
                 </a:solidFill>
                 <a:latin typeface="Calibri"/>
               </a:rPr>
-              <a:t>8981530463 (TANK; FUEL): EUR 1,645 to EUR 0, 8 fewer pieces.</a:t>
+              <a:t>8983320591 (NOZZLE ASM; INJ): EUR 1,321 to EUR 0, 7 fewer pieces.</a:t>
             </a:r>
           </a:p>
           <a:p>
@@ -13172,7 +12691,7 @@
                 </a:solidFill>
                 <a:latin typeface="Calibri"/>
               </a:rPr>
-              <a:t>8984890171 (PUMP ASM; FUEL,SUPPLY): EUR 3,409 to EUR 2,032, 2 fewer pieces.</a:t>
+              <a:t>8973865576 (PUMP ASM; INJ): EUR 886 to EUR 0, 1 fewer pieces.</a:t>
             </a:r>
           </a:p>
           <a:p>
@@ -13200,7 +12719,7 @@
                 </a:solidFill>
                 <a:latin typeface="Calibri"/>
               </a:rPr>
-              <a:t>8972745350 (TANK; FUEL): EUR 1,212 to EUR 0, 7 fewer pieces.</a:t>
+              <a:t>8982601090 (NOZZLE ASM; INJ): EUR 2,710 to EUR 1,909, 6 fewer pieces.</a:t>
             </a:r>
           </a:p>
         </p:txBody>
@@ -13286,7 +12805,7 @@
                 </a:solidFill>
                 <a:latin typeface="Calibri"/>
               </a:rPr>
-              <a:t>Is this pricing against what the dealers can buy locally?</a:t>
+              <a:t>Is this fewer failures, or repairs moving out of the network?</a:t>
             </a:r>
           </a:p>
           <a:p>
@@ -13314,7 +12833,7 @@
                 </a:solidFill>
                 <a:latin typeface="Calibri"/>
               </a:rPr>
-              <a:t>Is any of this stock timing on your side rather than end demand?</a:t>
+              <a:t>Is the exchange/reman route competing with new parts here?</a:t>
             </a:r>
           </a:p>
           <a:p>
@@ -13342,7 +12861,7 @@
                 </a:solidFill>
                 <a:latin typeface="Calibri"/>
               </a:rPr>
-              <a:t>What would make the biggest difference to keep this business with us?</a:t>
+              <a:t>Are dealers still quoting these part numbers, or have they dropped off the workshop menu?</a:t>
             </a:r>
           </a:p>
         </p:txBody>
@@ -13470,7 +12989,7 @@
                 </a:solidFill>
                 <a:latin typeface="Calibri"/>
               </a:rPr>
-              <a:t>PARTS PERFORMANCE — GROWTH</a:t>
+              <a:t>PARTS PERFORMANCE — FUEL SYSTEM</a:t>
             </a:r>
           </a:p>
         </p:txBody>
@@ -13505,7 +13024,7 @@
                 </a:solidFill>
                 <a:latin typeface="Calibri"/>
               </a:rPr>
-              <a:t>Where volume grew — CY H1 2026 vs CY H1 2025 (commercial, ex-warranty)</a:t>
+              <a:t>Fuel system — CY H1 2026 vs CY H1 2025 (commercial, ex-warranty)</a:t>
             </a:r>
           </a:p>
         </p:txBody>
@@ -13584,6 +13103,1182 @@
                 <a:latin typeface="Calibri"/>
               </a:rPr>
               <a:t>7</a:t>
+            </a:r>
+          </a:p>
+        </p:txBody>
+      </p:sp>
+      <p:sp>
+        <p:nvSpPr>
+          <p:cNvPr id="8" name="TextBox 7"/>
+          <p:cNvSpPr txBox="1"/>
+          <p:nvPr/>
+        </p:nvSpPr>
+        <p:spPr>
+          <a:xfrm>
+            <a:off x="292608" y="1207008"/>
+            <a:ext cx="11612880" cy="2651760"/>
+          </a:xfrm>
+          <a:prstGeom prst="rect">
+            <a:avLst/>
+          </a:prstGeom>
+          <a:noFill/>
+        </p:spPr>
+        <p:txBody>
+          <a:bodyPr wrap="square">
+            <a:spAutoFit/>
+          </a:bodyPr>
+          <a:lstStyle/>
+          <a:p>
+            <a:pPr>
+              <a:lnSpc>
+                <a:spcPct val="125000"/>
+              </a:lnSpc>
+              <a:spcAft>
+                <a:spcPts val="1000"/>
+              </a:spcAft>
+            </a:pPr>
+            <a:r>
+              <a:rPr sz="1300" b="1">
+                <a:solidFill>
+                  <a:srgbClr val="CC0E1E"/>
+                </a:solidFill>
+                <a:latin typeface="Calibri"/>
+              </a:rPr>
+              <a:t>—  </a:t>
+            </a:r>
+            <a:r>
+              <a:rPr sz="1300">
+                <a:solidFill>
+                  <a:srgbClr val="1A1A1A"/>
+                </a:solidFill>
+                <a:latin typeface="Calibri"/>
+              </a:rPr>
+              <a:t>EUR 9,894 (CY H1 2025) to EUR 5,548 (CY H1 2026), down EUR 4,346 (-44%).</a:t>
+            </a:r>
+          </a:p>
+          <a:p>
+            <a:pPr>
+              <a:lnSpc>
+                <a:spcPct val="125000"/>
+              </a:lnSpc>
+              <a:spcAft>
+                <a:spcPts val="1000"/>
+              </a:spcAft>
+            </a:pPr>
+            <a:r>
+              <a:rPr sz="1300" b="1">
+                <a:solidFill>
+                  <a:srgbClr val="CC0E1E"/>
+                </a:solidFill>
+                <a:latin typeface="Calibri"/>
+              </a:rPr>
+              <a:t>—  </a:t>
+            </a:r>
+            <a:r>
+              <a:rPr sz="1300">
+                <a:solidFill>
+                  <a:srgbClr val="1A1A1A"/>
+                </a:solidFill>
+                <a:latin typeface="Calibri"/>
+              </a:rPr>
+              <a:t>Largest part numbers driving the decline (by EUR):</a:t>
+            </a:r>
+          </a:p>
+          <a:p>
+            <a:pPr>
+              <a:lnSpc>
+                <a:spcPct val="125000"/>
+              </a:lnSpc>
+              <a:spcAft>
+                <a:spcPts val="1000"/>
+              </a:spcAft>
+            </a:pPr>
+            <a:r>
+              <a:rPr sz="1300" b="1">
+                <a:solidFill>
+                  <a:srgbClr val="CC0E1E"/>
+                </a:solidFill>
+                <a:latin typeface="Calibri"/>
+              </a:rPr>
+              <a:t>—  </a:t>
+            </a:r>
+            <a:r>
+              <a:rPr sz="1300">
+                <a:solidFill>
+                  <a:srgbClr val="1A1A1A"/>
+                </a:solidFill>
+                <a:latin typeface="Calibri"/>
+              </a:rPr>
+              <a:t>8941449334 (SEDIMENTER; FUEL): EUR 2,530 to EUR 0, 51 fewer pieces.</a:t>
+            </a:r>
+          </a:p>
+          <a:p>
+            <a:pPr>
+              <a:lnSpc>
+                <a:spcPct val="125000"/>
+              </a:lnSpc>
+              <a:spcAft>
+                <a:spcPts val="1000"/>
+              </a:spcAft>
+            </a:pPr>
+            <a:r>
+              <a:rPr sz="1300" b="1">
+                <a:solidFill>
+                  <a:srgbClr val="CC0E1E"/>
+                </a:solidFill>
+                <a:latin typeface="Calibri"/>
+              </a:rPr>
+              <a:t>—  </a:t>
+            </a:r>
+            <a:r>
+              <a:rPr sz="1300">
+                <a:solidFill>
+                  <a:srgbClr val="1A1A1A"/>
+                </a:solidFill>
+                <a:latin typeface="Calibri"/>
+              </a:rPr>
+              <a:t>8981530463 (TANK; FUEL): EUR 1,645 to EUR 0, 8 fewer pieces.</a:t>
+            </a:r>
+          </a:p>
+          <a:p>
+            <a:pPr>
+              <a:lnSpc>
+                <a:spcPct val="125000"/>
+              </a:lnSpc>
+              <a:spcAft>
+                <a:spcPts val="1000"/>
+              </a:spcAft>
+            </a:pPr>
+            <a:r>
+              <a:rPr sz="1300" b="1">
+                <a:solidFill>
+                  <a:srgbClr val="CC0E1E"/>
+                </a:solidFill>
+                <a:latin typeface="Calibri"/>
+              </a:rPr>
+              <a:t>—  </a:t>
+            </a:r>
+            <a:r>
+              <a:rPr sz="1300">
+                <a:solidFill>
+                  <a:srgbClr val="1A1A1A"/>
+                </a:solidFill>
+                <a:latin typeface="Calibri"/>
+              </a:rPr>
+              <a:t>8984890171 (PUMP ASM; FUEL,SUPPLY): EUR 3,409 to EUR 2,032, 2 fewer pieces.</a:t>
+            </a:r>
+          </a:p>
+          <a:p>
+            <a:pPr>
+              <a:lnSpc>
+                <a:spcPct val="125000"/>
+              </a:lnSpc>
+              <a:spcAft>
+                <a:spcPts val="1000"/>
+              </a:spcAft>
+            </a:pPr>
+            <a:r>
+              <a:rPr sz="1300" b="1">
+                <a:solidFill>
+                  <a:srgbClr val="CC0E1E"/>
+                </a:solidFill>
+                <a:latin typeface="Calibri"/>
+              </a:rPr>
+              <a:t>—  </a:t>
+            </a:r>
+            <a:r>
+              <a:rPr sz="1300">
+                <a:solidFill>
+                  <a:srgbClr val="1A1A1A"/>
+                </a:solidFill>
+                <a:latin typeface="Calibri"/>
+              </a:rPr>
+              <a:t>8972745350 (TANK; FUEL): EUR 1,212 to EUR 0, 7 fewer pieces.</a:t>
+            </a:r>
+          </a:p>
+        </p:txBody>
+      </p:sp>
+      <p:sp>
+        <p:nvSpPr>
+          <p:cNvPr id="9" name="TextBox 8"/>
+          <p:cNvSpPr txBox="1"/>
+          <p:nvPr/>
+        </p:nvSpPr>
+        <p:spPr>
+          <a:xfrm>
+            <a:off x="292608" y="3840480"/>
+            <a:ext cx="8595360" cy="274320"/>
+          </a:xfrm>
+          <a:prstGeom prst="rect">
+            <a:avLst/>
+          </a:prstGeom>
+          <a:noFill/>
+        </p:spPr>
+        <p:txBody>
+          <a:bodyPr wrap="square">
+            <a:spAutoFit/>
+          </a:bodyPr>
+          <a:lstStyle/>
+          <a:p>
+            <a:pPr algn="l"/>
+            <a:r>
+              <a:rPr sz="1300" b="1">
+                <a:solidFill>
+                  <a:srgbClr val="CC0E1E"/>
+                </a:solidFill>
+                <a:latin typeface="Calibri"/>
+              </a:rPr>
+              <a:t>Questions for us to work through together</a:t>
+            </a:r>
+          </a:p>
+        </p:txBody>
+      </p:sp>
+      <p:sp>
+        <p:nvSpPr>
+          <p:cNvPr id="10" name="TextBox 9"/>
+          <p:cNvSpPr txBox="1"/>
+          <p:nvPr/>
+        </p:nvSpPr>
+        <p:spPr>
+          <a:xfrm>
+            <a:off x="292608" y="4160520"/>
+            <a:ext cx="11612880" cy="1737360"/>
+          </a:xfrm>
+          <a:prstGeom prst="rect">
+            <a:avLst/>
+          </a:prstGeom>
+          <a:noFill/>
+        </p:spPr>
+        <p:txBody>
+          <a:bodyPr wrap="square">
+            <a:spAutoFit/>
+          </a:bodyPr>
+          <a:lstStyle/>
+          <a:p>
+            <a:pPr>
+              <a:lnSpc>
+                <a:spcPct val="125000"/>
+              </a:lnSpc>
+              <a:spcAft>
+                <a:spcPts val="1000"/>
+              </a:spcAft>
+            </a:pPr>
+            <a:r>
+              <a:rPr sz="1400" b="1">
+                <a:solidFill>
+                  <a:srgbClr val="CC0E1E"/>
+                </a:solidFill>
+                <a:latin typeface="Calibri"/>
+              </a:rPr>
+              <a:t>—  </a:t>
+            </a:r>
+            <a:r>
+              <a:rPr sz="1400">
+                <a:solidFill>
+                  <a:srgbClr val="1A1A1A"/>
+                </a:solidFill>
+                <a:latin typeface="Calibri"/>
+              </a:rPr>
+              <a:t>Is this pricing against what the dealers can buy locally?</a:t>
+            </a:r>
+          </a:p>
+          <a:p>
+            <a:pPr>
+              <a:lnSpc>
+                <a:spcPct val="125000"/>
+              </a:lnSpc>
+              <a:spcAft>
+                <a:spcPts val="1000"/>
+              </a:spcAft>
+            </a:pPr>
+            <a:r>
+              <a:rPr sz="1400" b="1">
+                <a:solidFill>
+                  <a:srgbClr val="CC0E1E"/>
+                </a:solidFill>
+                <a:latin typeface="Calibri"/>
+              </a:rPr>
+              <a:t>—  </a:t>
+            </a:r>
+            <a:r>
+              <a:rPr sz="1400">
+                <a:solidFill>
+                  <a:srgbClr val="1A1A1A"/>
+                </a:solidFill>
+                <a:latin typeface="Calibri"/>
+              </a:rPr>
+              <a:t>Is any of this stock timing on your side rather than end demand?</a:t>
+            </a:r>
+          </a:p>
+          <a:p>
+            <a:pPr>
+              <a:lnSpc>
+                <a:spcPct val="125000"/>
+              </a:lnSpc>
+              <a:spcAft>
+                <a:spcPts val="1000"/>
+              </a:spcAft>
+            </a:pPr>
+            <a:r>
+              <a:rPr sz="1400" b="1">
+                <a:solidFill>
+                  <a:srgbClr val="CC0E1E"/>
+                </a:solidFill>
+                <a:latin typeface="Calibri"/>
+              </a:rPr>
+              <a:t>—  </a:t>
+            </a:r>
+            <a:r>
+              <a:rPr sz="1400">
+                <a:solidFill>
+                  <a:srgbClr val="1A1A1A"/>
+                </a:solidFill>
+                <a:latin typeface="Calibri"/>
+              </a:rPr>
+              <a:t>What would make the biggest difference to keep this business with us?</a:t>
+            </a:r>
+          </a:p>
+        </p:txBody>
+      </p:sp>
+    </p:spTree>
+  </p:cSld>
+  <p:clrMapOvr>
+    <a:masterClrMapping/>
+  </p:clrMapOvr>
+</p:sld>
+</file>
+
+<file path=ppt/slides/slide8.xml><?xml version="1.0" encoding="utf-8"?>
+<p:sld xmlns:a="http://schemas.openxmlformats.org/drawingml/2006/main" xmlns:p="http://schemas.openxmlformats.org/presentationml/2006/main" xmlns:r="http://schemas.openxmlformats.org/officeDocument/2006/relationships">
+  <p:cSld>
+    <p:bg>
+      <p:bgPr>
+        <a:solidFill>
+          <a:srgbClr val="FFFFFF"/>
+        </a:solidFill>
+        <a:effectLst/>
+      </p:bgPr>
+    </p:bg>
+    <p:spTree>
+      <p:nvGrpSpPr>
+        <p:cNvPr id="1" name=""/>
+        <p:cNvGrpSpPr/>
+        <p:nvPr/>
+      </p:nvGrpSpPr>
+      <p:grpSpPr/>
+      <p:pic>
+        <p:nvPicPr>
+          <p:cNvPr id="2" name="Picture 1" descr="isuzu_logo_red.png"/>
+          <p:cNvPicPr>
+            <a:picLocks noChangeAspect="1"/>
+          </p:cNvPicPr>
+          <p:nvPr/>
+        </p:nvPicPr>
+        <p:blipFill>
+          <a:blip r:embed="rId2"/>
+          <a:stretch>
+            <a:fillRect/>
+          </a:stretch>
+        </p:blipFill>
+        <p:spPr>
+          <a:xfrm>
+            <a:off x="256032" y="6263640"/>
+            <a:ext cx="1679787" cy="292608"/>
+          </a:xfrm>
+          <a:prstGeom prst="rect">
+            <a:avLst/>
+          </a:prstGeom>
+        </p:spPr>
+      </p:pic>
+      <p:sp>
+        <p:nvSpPr>
+          <p:cNvPr id="3" name="Rectangle 2"/>
+          <p:cNvSpPr/>
+          <p:nvPr/>
+        </p:nvSpPr>
+        <p:spPr>
+          <a:xfrm>
+            <a:off x="0" y="6766560"/>
+            <a:ext cx="12188952" cy="91440"/>
+          </a:xfrm>
+          <a:prstGeom prst="rect">
+            <a:avLst/>
+          </a:prstGeom>
+          <a:solidFill>
+            <a:srgbClr val="CC0E1E"/>
+          </a:solidFill>
+          <a:ln>
+            <a:noFill/>
+          </a:ln>
+        </p:spPr>
+        <p:style>
+          <a:lnRef idx="1">
+            <a:schemeClr val="accent1"/>
+          </a:lnRef>
+          <a:fillRef idx="3">
+            <a:schemeClr val="accent1"/>
+          </a:fillRef>
+          <a:effectRef idx="2">
+            <a:schemeClr val="accent1"/>
+          </a:effectRef>
+          <a:fontRef idx="minor">
+            <a:schemeClr val="lt1"/>
+          </a:fontRef>
+        </p:style>
+        <p:txBody>
+          <a:bodyPr rtlCol="0" anchor="ctr"/>
+          <a:lstStyle/>
+          <a:p>
+            <a:pPr algn="ctr"/>
+          </a:p>
+        </p:txBody>
+      </p:sp>
+      <p:sp>
+        <p:nvSpPr>
+          <p:cNvPr id="4" name="TextBox 3"/>
+          <p:cNvSpPr txBox="1"/>
+          <p:nvPr/>
+        </p:nvSpPr>
+        <p:spPr>
+          <a:xfrm>
+            <a:off x="292608" y="201168"/>
+            <a:ext cx="11430000" cy="274320"/>
+          </a:xfrm>
+          <a:prstGeom prst="rect">
+            <a:avLst/>
+          </a:prstGeom>
+          <a:noFill/>
+        </p:spPr>
+        <p:txBody>
+          <a:bodyPr wrap="square">
+            <a:spAutoFit/>
+          </a:bodyPr>
+          <a:lstStyle/>
+          <a:p>
+            <a:pPr algn="l"/>
+            <a:r>
+              <a:rPr sz="1100" b="1">
+                <a:solidFill>
+                  <a:srgbClr val="CC0E1E"/>
+                </a:solidFill>
+                <a:latin typeface="Calibri"/>
+              </a:rPr>
+              <a:t>PARTS PERFORMANCE — BODY PARTS</a:t>
+            </a:r>
+          </a:p>
+        </p:txBody>
+      </p:sp>
+      <p:sp>
+        <p:nvSpPr>
+          <p:cNvPr id="5" name="TextBox 4"/>
+          <p:cNvSpPr txBox="1"/>
+          <p:nvPr/>
+        </p:nvSpPr>
+        <p:spPr>
+          <a:xfrm>
+            <a:off x="292608" y="475488"/>
+            <a:ext cx="11612880" cy="566928"/>
+          </a:xfrm>
+          <a:prstGeom prst="rect">
+            <a:avLst/>
+          </a:prstGeom>
+          <a:noFill/>
+        </p:spPr>
+        <p:txBody>
+          <a:bodyPr wrap="square">
+            <a:spAutoFit/>
+          </a:bodyPr>
+          <a:lstStyle/>
+          <a:p>
+            <a:pPr algn="l"/>
+            <a:r>
+              <a:rPr sz="2500" b="1">
+                <a:solidFill>
+                  <a:srgbClr val="1A1A1A"/>
+                </a:solidFill>
+                <a:latin typeface="Calibri"/>
+              </a:rPr>
+              <a:t>Body parts — CY H1 2026 vs CY H1 2025 (commercial, ex-warranty)</a:t>
+            </a:r>
+          </a:p>
+        </p:txBody>
+      </p:sp>
+      <p:sp>
+        <p:nvSpPr>
+          <p:cNvPr id="6" name="Rectangle 5"/>
+          <p:cNvSpPr/>
+          <p:nvPr/>
+        </p:nvSpPr>
+        <p:spPr>
+          <a:xfrm>
+            <a:off x="292608" y="1005840"/>
+            <a:ext cx="11612880" cy="28000"/>
+          </a:xfrm>
+          <a:prstGeom prst="rect">
+            <a:avLst/>
+          </a:prstGeom>
+          <a:solidFill>
+            <a:srgbClr val="CC0E1E"/>
+          </a:solidFill>
+          <a:ln>
+            <a:noFill/>
+          </a:ln>
+        </p:spPr>
+        <p:style>
+          <a:lnRef idx="1">
+            <a:schemeClr val="accent1"/>
+          </a:lnRef>
+          <a:fillRef idx="3">
+            <a:schemeClr val="accent1"/>
+          </a:fillRef>
+          <a:effectRef idx="2">
+            <a:schemeClr val="accent1"/>
+          </a:effectRef>
+          <a:fontRef idx="minor">
+            <a:schemeClr val="lt1"/>
+          </a:fontRef>
+        </p:style>
+        <p:txBody>
+          <a:bodyPr rtlCol="0" anchor="ctr"/>
+          <a:lstStyle/>
+          <a:p>
+            <a:pPr algn="ctr"/>
+          </a:p>
+        </p:txBody>
+      </p:sp>
+      <p:sp>
+        <p:nvSpPr>
+          <p:cNvPr id="7" name="TextBox 6"/>
+          <p:cNvSpPr txBox="1"/>
+          <p:nvPr/>
+        </p:nvSpPr>
+        <p:spPr>
+          <a:xfrm>
+            <a:off x="11594592" y="6473952"/>
+            <a:ext cx="365760" cy="274320"/>
+          </a:xfrm>
+          <a:prstGeom prst="rect">
+            <a:avLst/>
+          </a:prstGeom>
+          <a:noFill/>
+        </p:spPr>
+        <p:txBody>
+          <a:bodyPr wrap="square">
+            <a:spAutoFit/>
+          </a:bodyPr>
+          <a:lstStyle/>
+          <a:p>
+            <a:pPr algn="r"/>
+            <a:r>
+              <a:rPr sz="1000" b="0">
+                <a:solidFill>
+                  <a:srgbClr val="5A5A5A"/>
+                </a:solidFill>
+                <a:latin typeface="Calibri"/>
+              </a:rPr>
+              <a:t>8</a:t>
+            </a:r>
+          </a:p>
+        </p:txBody>
+      </p:sp>
+      <p:sp>
+        <p:nvSpPr>
+          <p:cNvPr id="8" name="TextBox 7"/>
+          <p:cNvSpPr txBox="1"/>
+          <p:nvPr/>
+        </p:nvSpPr>
+        <p:spPr>
+          <a:xfrm>
+            <a:off x="292608" y="1207008"/>
+            <a:ext cx="11612880" cy="2926080"/>
+          </a:xfrm>
+          <a:prstGeom prst="rect">
+            <a:avLst/>
+          </a:prstGeom>
+          <a:noFill/>
+        </p:spPr>
+        <p:txBody>
+          <a:bodyPr wrap="square">
+            <a:spAutoFit/>
+          </a:bodyPr>
+          <a:lstStyle/>
+          <a:p>
+            <a:pPr>
+              <a:lnSpc>
+                <a:spcPct val="125000"/>
+              </a:lnSpc>
+              <a:spcAft>
+                <a:spcPts val="1000"/>
+              </a:spcAft>
+            </a:pPr>
+            <a:r>
+              <a:rPr sz="1300" b="1">
+                <a:solidFill>
+                  <a:srgbClr val="CC0E1E"/>
+                </a:solidFill>
+                <a:latin typeface="Calibri"/>
+              </a:rPr>
+              <a:t>—  </a:t>
+            </a:r>
+            <a:r>
+              <a:rPr sz="1300">
+                <a:solidFill>
+                  <a:srgbClr val="1A1A1A"/>
+                </a:solidFill>
+                <a:latin typeface="Calibri"/>
+              </a:rPr>
+              <a:t>EUR 286,109 (CY H1 2025) to EUR 388,275 (CY H1 2026), up EUR 102,166 (+36%).</a:t>
+            </a:r>
+          </a:p>
+          <a:p>
+            <a:pPr>
+              <a:lnSpc>
+                <a:spcPct val="125000"/>
+              </a:lnSpc>
+              <a:spcAft>
+                <a:spcPts val="1000"/>
+              </a:spcAft>
+            </a:pPr>
+            <a:r>
+              <a:rPr sz="1300" b="1">
+                <a:solidFill>
+                  <a:srgbClr val="CC0E1E"/>
+                </a:solidFill>
+                <a:latin typeface="Calibri"/>
+              </a:rPr>
+              <a:t>—  </a:t>
+            </a:r>
+            <a:r>
+              <a:rPr sz="1300">
+                <a:solidFill>
+                  <a:srgbClr val="1A1A1A"/>
+                </a:solidFill>
+                <a:latin typeface="Calibri"/>
+              </a:rPr>
+              <a:t>Largest part numbers driving the increase (by EUR):</a:t>
+            </a:r>
+          </a:p>
+          <a:p>
+            <a:pPr>
+              <a:lnSpc>
+                <a:spcPct val="125000"/>
+              </a:lnSpc>
+              <a:spcAft>
+                <a:spcPts val="1000"/>
+              </a:spcAft>
+            </a:pPr>
+            <a:r>
+              <a:rPr sz="1300" b="1">
+                <a:solidFill>
+                  <a:srgbClr val="CC0E1E"/>
+                </a:solidFill>
+                <a:latin typeface="Calibri"/>
+              </a:rPr>
+              <a:t>—  </a:t>
+            </a:r>
+            <a:r>
+              <a:rPr sz="1300">
+                <a:solidFill>
+                  <a:srgbClr val="1A1A1A"/>
+                </a:solidFill>
+                <a:latin typeface="Calibri"/>
+              </a:rPr>
+              <a:t>8978461152 (GLASS; WINDSHIELD): EUR 697 to EUR 18,240, +79 pcs.</a:t>
+            </a:r>
+          </a:p>
+          <a:p>
+            <a:pPr>
+              <a:lnSpc>
+                <a:spcPct val="125000"/>
+              </a:lnSpc>
+              <a:spcAft>
+                <a:spcPts val="1000"/>
+              </a:spcAft>
+            </a:pPr>
+            <a:r>
+              <a:rPr sz="1300" b="1">
+                <a:solidFill>
+                  <a:srgbClr val="CC0E1E"/>
+                </a:solidFill>
+                <a:latin typeface="Calibri"/>
+              </a:rPr>
+              <a:t>—  </a:t>
+            </a:r>
+            <a:r>
+              <a:rPr sz="1300">
+                <a:solidFill>
+                  <a:srgbClr val="1A1A1A"/>
+                </a:solidFill>
+                <a:latin typeface="Calibri"/>
+              </a:rPr>
+              <a:t>8975595830 (PANEL; SIDE GATE): EUR 2,154 to EUR 6,389, +19 pcs.</a:t>
+            </a:r>
+          </a:p>
+          <a:p>
+            <a:pPr>
+              <a:lnSpc>
+                <a:spcPct val="125000"/>
+              </a:lnSpc>
+              <a:spcAft>
+                <a:spcPts val="1000"/>
+              </a:spcAft>
+            </a:pPr>
+            <a:r>
+              <a:rPr sz="1300" b="1">
+                <a:solidFill>
+                  <a:srgbClr val="CC0E1E"/>
+                </a:solidFill>
+                <a:latin typeface="Calibri"/>
+              </a:rPr>
+              <a:t>—  </a:t>
+            </a:r>
+            <a:r>
+              <a:rPr sz="1300">
+                <a:solidFill>
+                  <a:srgbClr val="1A1A1A"/>
+                </a:solidFill>
+                <a:latin typeface="Calibri"/>
+              </a:rPr>
+              <a:t>7552172691 (BUMPER ASM; FRT): EUR 753 to EUR 4,765, +26 pcs.</a:t>
+            </a:r>
+          </a:p>
+          <a:p>
+            <a:pPr>
+              <a:lnSpc>
+                <a:spcPct val="125000"/>
+              </a:lnSpc>
+              <a:spcAft>
+                <a:spcPts val="1000"/>
+              </a:spcAft>
+            </a:pPr>
+            <a:r>
+              <a:rPr sz="1300" b="1">
+                <a:solidFill>
+                  <a:srgbClr val="CC0E1E"/>
+                </a:solidFill>
+                <a:latin typeface="Calibri"/>
+              </a:rPr>
+              <a:t>—  </a:t>
+            </a:r>
+            <a:r>
+              <a:rPr sz="1300">
+                <a:solidFill>
+                  <a:srgbClr val="1A1A1A"/>
+                </a:solidFill>
+                <a:latin typeface="Calibri"/>
+              </a:rPr>
+              <a:t>8983410105 (BUMPER ASM; FRT): EUR 1,387 to EUR 4,581, +29 pcs.</a:t>
+            </a:r>
+          </a:p>
+          <a:p>
+            <a:pPr>
+              <a:lnSpc>
+                <a:spcPct val="125000"/>
+              </a:lnSpc>
+              <a:spcAft>
+                <a:spcPts val="1000"/>
+              </a:spcAft>
+            </a:pPr>
+            <a:r>
+              <a:rPr sz="1300" b="1">
+                <a:solidFill>
+                  <a:srgbClr val="CC0E1E"/>
+                </a:solidFill>
+                <a:latin typeface="Calibri"/>
+              </a:rPr>
+              <a:t>—  </a:t>
+            </a:r>
+            <a:r>
+              <a:rPr sz="1300">
+                <a:solidFill>
+                  <a:srgbClr val="1A1A1A"/>
+                </a:solidFill>
+                <a:latin typeface="Calibri"/>
+              </a:rPr>
+              <a:t>Largest Body declines: 8974725274 (RAIL; ROOF) EUR -4K, 34 fewer pcs; 8974725284 (RAIL; ROOF) EUR -4K, 33 fewer pcs.</a:t>
+            </a:r>
+          </a:p>
+        </p:txBody>
+      </p:sp>
+      <p:sp>
+        <p:nvSpPr>
+          <p:cNvPr id="9" name="TextBox 8"/>
+          <p:cNvSpPr txBox="1"/>
+          <p:nvPr/>
+        </p:nvSpPr>
+        <p:spPr>
+          <a:xfrm>
+            <a:off x="292608" y="4160520"/>
+            <a:ext cx="8595360" cy="274320"/>
+          </a:xfrm>
+          <a:prstGeom prst="rect">
+            <a:avLst/>
+          </a:prstGeom>
+          <a:noFill/>
+        </p:spPr>
+        <p:txBody>
+          <a:bodyPr wrap="square">
+            <a:spAutoFit/>
+          </a:bodyPr>
+          <a:lstStyle/>
+          <a:p>
+            <a:pPr algn="l"/>
+            <a:r>
+              <a:rPr sz="1300" b="1">
+                <a:solidFill>
+                  <a:srgbClr val="CC0E1E"/>
+                </a:solidFill>
+                <a:latin typeface="Calibri"/>
+              </a:rPr>
+              <a:t>Questions for us to work through together</a:t>
+            </a:r>
+          </a:p>
+        </p:txBody>
+      </p:sp>
+      <p:sp>
+        <p:nvSpPr>
+          <p:cNvPr id="10" name="TextBox 9"/>
+          <p:cNvSpPr txBox="1"/>
+          <p:nvPr/>
+        </p:nvSpPr>
+        <p:spPr>
+          <a:xfrm>
+            <a:off x="292608" y="4480560"/>
+            <a:ext cx="11612880" cy="1463040"/>
+          </a:xfrm>
+          <a:prstGeom prst="rect">
+            <a:avLst/>
+          </a:prstGeom>
+          <a:noFill/>
+        </p:spPr>
+        <p:txBody>
+          <a:bodyPr wrap="square">
+            <a:spAutoFit/>
+          </a:bodyPr>
+          <a:lstStyle/>
+          <a:p>
+            <a:pPr>
+              <a:lnSpc>
+                <a:spcPct val="125000"/>
+              </a:lnSpc>
+              <a:spcAft>
+                <a:spcPts val="1000"/>
+              </a:spcAft>
+            </a:pPr>
+            <a:r>
+              <a:rPr sz="1400" b="1">
+                <a:solidFill>
+                  <a:srgbClr val="CC0E1E"/>
+                </a:solidFill>
+                <a:latin typeface="Calibri"/>
+              </a:rPr>
+              <a:t>—  </a:t>
+            </a:r>
+            <a:r>
+              <a:rPr sz="1400">
+                <a:solidFill>
+                  <a:srgbClr val="1A1A1A"/>
+                </a:solidFill>
+                <a:latin typeface="Calibri"/>
+              </a:rPr>
+              <a:t>Is this collision / glass volume from a few fleet events, or a sustained workshop pattern?</a:t>
+            </a:r>
+          </a:p>
+          <a:p>
+            <a:pPr>
+              <a:lnSpc>
+                <a:spcPct val="125000"/>
+              </a:lnSpc>
+              <a:spcAft>
+                <a:spcPts val="1000"/>
+              </a:spcAft>
+            </a:pPr>
+            <a:r>
+              <a:rPr sz="1400" b="1">
+                <a:solidFill>
+                  <a:srgbClr val="CC0E1E"/>
+                </a:solidFill>
+                <a:latin typeface="Calibri"/>
+              </a:rPr>
+              <a:t>—  </a:t>
+            </a:r>
+            <a:r>
+              <a:rPr sz="1400">
+                <a:solidFill>
+                  <a:srgbClr val="1A1A1A"/>
+                </a:solidFill>
+                <a:latin typeface="Calibri"/>
+              </a:rPr>
+              <a:t>Are windshields and bumpers staying with the network, or is bodywork leaking to IAM?</a:t>
+            </a:r>
+          </a:p>
+          <a:p>
+            <a:pPr>
+              <a:lnSpc>
+                <a:spcPct val="125000"/>
+              </a:lnSpc>
+              <a:spcAft>
+                <a:spcPts val="1000"/>
+              </a:spcAft>
+            </a:pPr>
+            <a:r>
+              <a:rPr sz="1400" b="1">
+                <a:solidFill>
+                  <a:srgbClr val="CC0E1E"/>
+                </a:solidFill>
+                <a:latin typeface="Calibri"/>
+              </a:rPr>
+              <a:t>—  </a:t>
+            </a:r>
+            <a:r>
+              <a:rPr sz="1400">
+                <a:solidFill>
+                  <a:srgbClr val="1A1A1A"/>
+                </a:solidFill>
+                <a:latin typeface="Calibri"/>
+              </a:rPr>
+              <a:t>Which models drive the glass and bumper PNs — and is stock aligned?</a:t>
+            </a:r>
+          </a:p>
+        </p:txBody>
+      </p:sp>
+    </p:spTree>
+  </p:cSld>
+  <p:clrMapOvr>
+    <a:masterClrMapping/>
+  </p:clrMapOvr>
+</p:sld>
+</file>
+
+<file path=ppt/slides/slide9.xml><?xml version="1.0" encoding="utf-8"?>
+<p:sld xmlns:a="http://schemas.openxmlformats.org/drawingml/2006/main" xmlns:p="http://schemas.openxmlformats.org/presentationml/2006/main" xmlns:r="http://schemas.openxmlformats.org/officeDocument/2006/relationships">
+  <p:cSld>
+    <p:bg>
+      <p:bgPr>
+        <a:solidFill>
+          <a:srgbClr val="FFFFFF"/>
+        </a:solidFill>
+        <a:effectLst/>
+      </p:bgPr>
+    </p:bg>
+    <p:spTree>
+      <p:nvGrpSpPr>
+        <p:cNvPr id="1" name=""/>
+        <p:cNvGrpSpPr/>
+        <p:nvPr/>
+      </p:nvGrpSpPr>
+      <p:grpSpPr/>
+      <p:pic>
+        <p:nvPicPr>
+          <p:cNvPr id="2" name="Picture 1" descr="isuzu_logo_red.png"/>
+          <p:cNvPicPr>
+            <a:picLocks noChangeAspect="1"/>
+          </p:cNvPicPr>
+          <p:nvPr/>
+        </p:nvPicPr>
+        <p:blipFill>
+          <a:blip r:embed="rId2"/>
+          <a:stretch>
+            <a:fillRect/>
+          </a:stretch>
+        </p:blipFill>
+        <p:spPr>
+          <a:xfrm>
+            <a:off x="256032" y="6263640"/>
+            <a:ext cx="1679787" cy="292608"/>
+          </a:xfrm>
+          <a:prstGeom prst="rect">
+            <a:avLst/>
+          </a:prstGeom>
+        </p:spPr>
+      </p:pic>
+      <p:sp>
+        <p:nvSpPr>
+          <p:cNvPr id="3" name="Rectangle 2"/>
+          <p:cNvSpPr/>
+          <p:nvPr/>
+        </p:nvSpPr>
+        <p:spPr>
+          <a:xfrm>
+            <a:off x="0" y="6766560"/>
+            <a:ext cx="12188952" cy="91440"/>
+          </a:xfrm>
+          <a:prstGeom prst="rect">
+            <a:avLst/>
+          </a:prstGeom>
+          <a:solidFill>
+            <a:srgbClr val="CC0E1E"/>
+          </a:solidFill>
+          <a:ln>
+            <a:noFill/>
+          </a:ln>
+        </p:spPr>
+        <p:style>
+          <a:lnRef idx="1">
+            <a:schemeClr val="accent1"/>
+          </a:lnRef>
+          <a:fillRef idx="3">
+            <a:schemeClr val="accent1"/>
+          </a:fillRef>
+          <a:effectRef idx="2">
+            <a:schemeClr val="accent1"/>
+          </a:effectRef>
+          <a:fontRef idx="minor">
+            <a:schemeClr val="lt1"/>
+          </a:fontRef>
+        </p:style>
+        <p:txBody>
+          <a:bodyPr rtlCol="0" anchor="ctr"/>
+          <a:lstStyle/>
+          <a:p>
+            <a:pPr algn="ctr"/>
+          </a:p>
+        </p:txBody>
+      </p:sp>
+      <p:sp>
+        <p:nvSpPr>
+          <p:cNvPr id="4" name="TextBox 3"/>
+          <p:cNvSpPr txBox="1"/>
+          <p:nvPr/>
+        </p:nvSpPr>
+        <p:spPr>
+          <a:xfrm>
+            <a:off x="292608" y="201168"/>
+            <a:ext cx="11430000" cy="274320"/>
+          </a:xfrm>
+          <a:prstGeom prst="rect">
+            <a:avLst/>
+          </a:prstGeom>
+          <a:noFill/>
+        </p:spPr>
+        <p:txBody>
+          <a:bodyPr wrap="square">
+            <a:spAutoFit/>
+          </a:bodyPr>
+          <a:lstStyle/>
+          <a:p>
+            <a:pPr algn="l"/>
+            <a:r>
+              <a:rPr sz="1100" b="1">
+                <a:solidFill>
+                  <a:srgbClr val="CC0E1E"/>
+                </a:solidFill>
+                <a:latin typeface="Calibri"/>
+              </a:rPr>
+              <a:t>PARTS PERFORMANCE — GROWTH</a:t>
+            </a:r>
+          </a:p>
+        </p:txBody>
+      </p:sp>
+      <p:sp>
+        <p:nvSpPr>
+          <p:cNvPr id="5" name="TextBox 4"/>
+          <p:cNvSpPr txBox="1"/>
+          <p:nvPr/>
+        </p:nvSpPr>
+        <p:spPr>
+          <a:xfrm>
+            <a:off x="292608" y="475488"/>
+            <a:ext cx="11612880" cy="566928"/>
+          </a:xfrm>
+          <a:prstGeom prst="rect">
+            <a:avLst/>
+          </a:prstGeom>
+          <a:noFill/>
+        </p:spPr>
+        <p:txBody>
+          <a:bodyPr wrap="square">
+            <a:spAutoFit/>
+          </a:bodyPr>
+          <a:lstStyle/>
+          <a:p>
+            <a:pPr algn="l"/>
+            <a:r>
+              <a:rPr sz="2500" b="1">
+                <a:solidFill>
+                  <a:srgbClr val="1A1A1A"/>
+                </a:solidFill>
+                <a:latin typeface="Calibri"/>
+              </a:rPr>
+              <a:t>Where volume grew — CY H1 2026 vs CY H1 2025 (commercial, ex-warranty)</a:t>
+            </a:r>
+          </a:p>
+        </p:txBody>
+      </p:sp>
+      <p:sp>
+        <p:nvSpPr>
+          <p:cNvPr id="6" name="Rectangle 5"/>
+          <p:cNvSpPr/>
+          <p:nvPr/>
+        </p:nvSpPr>
+        <p:spPr>
+          <a:xfrm>
+            <a:off x="292608" y="1005840"/>
+            <a:ext cx="11612880" cy="28000"/>
+          </a:xfrm>
+          <a:prstGeom prst="rect">
+            <a:avLst/>
+          </a:prstGeom>
+          <a:solidFill>
+            <a:srgbClr val="CC0E1E"/>
+          </a:solidFill>
+          <a:ln>
+            <a:noFill/>
+          </a:ln>
+        </p:spPr>
+        <p:style>
+          <a:lnRef idx="1">
+            <a:schemeClr val="accent1"/>
+          </a:lnRef>
+          <a:fillRef idx="3">
+            <a:schemeClr val="accent1"/>
+          </a:fillRef>
+          <a:effectRef idx="2">
+            <a:schemeClr val="accent1"/>
+          </a:effectRef>
+          <a:fontRef idx="minor">
+            <a:schemeClr val="lt1"/>
+          </a:fontRef>
+        </p:style>
+        <p:txBody>
+          <a:bodyPr rtlCol="0" anchor="ctr"/>
+          <a:lstStyle/>
+          <a:p>
+            <a:pPr algn="ctr"/>
+          </a:p>
+        </p:txBody>
+      </p:sp>
+      <p:sp>
+        <p:nvSpPr>
+          <p:cNvPr id="7" name="TextBox 6"/>
+          <p:cNvSpPr txBox="1"/>
+          <p:nvPr/>
+        </p:nvSpPr>
+        <p:spPr>
+          <a:xfrm>
+            <a:off x="11594592" y="6473952"/>
+            <a:ext cx="365760" cy="274320"/>
+          </a:xfrm>
+          <a:prstGeom prst="rect">
+            <a:avLst/>
+          </a:prstGeom>
+          <a:noFill/>
+        </p:spPr>
+        <p:txBody>
+          <a:bodyPr wrap="square">
+            <a:spAutoFit/>
+          </a:bodyPr>
+          <a:lstStyle/>
+          <a:p>
+            <a:pPr algn="r"/>
+            <a:r>
+              <a:rPr sz="1000" b="0">
+                <a:solidFill>
+                  <a:srgbClr val="5A5A5A"/>
+                </a:solidFill>
+                <a:latin typeface="Calibri"/>
+              </a:rPr>
+              <a:t>9</a:t>
             </a:r>
           </a:p>
         </p:txBody>
@@ -14713,1388 +15408,6 @@
 </p:sld>
 </file>
 
-<file path=ppt/slides/slide8.xml><?xml version="1.0" encoding="utf-8"?>
-<p:sld xmlns:a="http://schemas.openxmlformats.org/drawingml/2006/main" xmlns:p="http://schemas.openxmlformats.org/presentationml/2006/main" xmlns:r="http://schemas.openxmlformats.org/officeDocument/2006/relationships">
-  <p:cSld>
-    <p:bg>
-      <p:bgPr>
-        <a:solidFill>
-          <a:srgbClr val="FFFFFF"/>
-        </a:solidFill>
-        <a:effectLst/>
-      </p:bgPr>
-    </p:bg>
-    <p:spTree>
-      <p:nvGrpSpPr>
-        <p:cNvPr id="1" name=""/>
-        <p:cNvGrpSpPr/>
-        <p:nvPr/>
-      </p:nvGrpSpPr>
-      <p:grpSpPr/>
-      <p:pic>
-        <p:nvPicPr>
-          <p:cNvPr id="2" name="Picture 1" descr="isuzu_logo_red.png"/>
-          <p:cNvPicPr>
-            <a:picLocks noChangeAspect="1"/>
-          </p:cNvPicPr>
-          <p:nvPr/>
-        </p:nvPicPr>
-        <p:blipFill>
-          <a:blip r:embed="rId2"/>
-          <a:stretch>
-            <a:fillRect/>
-          </a:stretch>
-        </p:blipFill>
-        <p:spPr>
-          <a:xfrm>
-            <a:off x="256032" y="6263640"/>
-            <a:ext cx="1679787" cy="292608"/>
-          </a:xfrm>
-          <a:prstGeom prst="rect">
-            <a:avLst/>
-          </a:prstGeom>
-        </p:spPr>
-      </p:pic>
-      <p:sp>
-        <p:nvSpPr>
-          <p:cNvPr id="3" name="Rectangle 2"/>
-          <p:cNvSpPr/>
-          <p:nvPr/>
-        </p:nvSpPr>
-        <p:spPr>
-          <a:xfrm>
-            <a:off x="0" y="6766560"/>
-            <a:ext cx="12188952" cy="91440"/>
-          </a:xfrm>
-          <a:prstGeom prst="rect">
-            <a:avLst/>
-          </a:prstGeom>
-          <a:solidFill>
-            <a:srgbClr val="CC0E1E"/>
-          </a:solidFill>
-          <a:ln>
-            <a:noFill/>
-          </a:ln>
-        </p:spPr>
-        <p:style>
-          <a:lnRef idx="1">
-            <a:schemeClr val="accent1"/>
-          </a:lnRef>
-          <a:fillRef idx="3">
-            <a:schemeClr val="accent1"/>
-          </a:fillRef>
-          <a:effectRef idx="2">
-            <a:schemeClr val="accent1"/>
-          </a:effectRef>
-          <a:fontRef idx="minor">
-            <a:schemeClr val="lt1"/>
-          </a:fontRef>
-        </p:style>
-        <p:txBody>
-          <a:bodyPr rtlCol="0" anchor="ctr"/>
-          <a:lstStyle/>
-          <a:p>
-            <a:pPr algn="ctr"/>
-          </a:p>
-        </p:txBody>
-      </p:sp>
-      <p:sp>
-        <p:nvSpPr>
-          <p:cNvPr id="4" name="TextBox 3"/>
-          <p:cNvSpPr txBox="1"/>
-          <p:nvPr/>
-        </p:nvSpPr>
-        <p:spPr>
-          <a:xfrm>
-            <a:off x="292608" y="201168"/>
-            <a:ext cx="11430000" cy="274320"/>
-          </a:xfrm>
-          <a:prstGeom prst="rect">
-            <a:avLst/>
-          </a:prstGeom>
-          <a:noFill/>
-        </p:spPr>
-        <p:txBody>
-          <a:bodyPr wrap="square">
-            <a:spAutoFit/>
-          </a:bodyPr>
-          <a:lstStyle/>
-          <a:p>
-            <a:pPr algn="l"/>
-            <a:r>
-              <a:rPr sz="1100" b="1">
-                <a:solidFill>
-                  <a:srgbClr val="CC0E1E"/>
-                </a:solidFill>
-                <a:latin typeface="Calibri"/>
-              </a:rPr>
-              <a:t>PARTS PERFORMANCE</a:t>
-            </a:r>
-          </a:p>
-        </p:txBody>
-      </p:sp>
-      <p:sp>
-        <p:nvSpPr>
-          <p:cNvPr id="5" name="TextBox 4"/>
-          <p:cNvSpPr txBox="1"/>
-          <p:nvPr/>
-        </p:nvSpPr>
-        <p:spPr>
-          <a:xfrm>
-            <a:off x="292608" y="475488"/>
-            <a:ext cx="11612880" cy="566928"/>
-          </a:xfrm>
-          <a:prstGeom prst="rect">
-            <a:avLst/>
-          </a:prstGeom>
-          <a:noFill/>
-        </p:spPr>
-        <p:txBody>
-          <a:bodyPr wrap="square">
-            <a:spAutoFit/>
-          </a:bodyPr>
-          <a:lstStyle/>
-          <a:p>
-            <a:pPr algn="l"/>
-            <a:r>
-              <a:rPr sz="2500" b="1">
-                <a:solidFill>
-                  <a:srgbClr val="1A1A1A"/>
-                </a:solidFill>
-                <a:latin typeface="Calibri"/>
-              </a:rPr>
-              <a:t>New Business — validation queue (CY H1 2026)</a:t>
-            </a:r>
-          </a:p>
-        </p:txBody>
-      </p:sp>
-      <p:sp>
-        <p:nvSpPr>
-          <p:cNvPr id="6" name="Rectangle 5"/>
-          <p:cNvSpPr/>
-          <p:nvPr/>
-        </p:nvSpPr>
-        <p:spPr>
-          <a:xfrm>
-            <a:off x="292608" y="1005840"/>
-            <a:ext cx="11612880" cy="28000"/>
-          </a:xfrm>
-          <a:prstGeom prst="rect">
-            <a:avLst/>
-          </a:prstGeom>
-          <a:solidFill>
-            <a:srgbClr val="CC0E1E"/>
-          </a:solidFill>
-          <a:ln>
-            <a:noFill/>
-          </a:ln>
-        </p:spPr>
-        <p:style>
-          <a:lnRef idx="1">
-            <a:schemeClr val="accent1"/>
-          </a:lnRef>
-          <a:fillRef idx="3">
-            <a:schemeClr val="accent1"/>
-          </a:fillRef>
-          <a:effectRef idx="2">
-            <a:schemeClr val="accent1"/>
-          </a:effectRef>
-          <a:fontRef idx="minor">
-            <a:schemeClr val="lt1"/>
-          </a:fontRef>
-        </p:style>
-        <p:txBody>
-          <a:bodyPr rtlCol="0" anchor="ctr"/>
-          <a:lstStyle/>
-          <a:p>
-            <a:pPr algn="ctr"/>
-          </a:p>
-        </p:txBody>
-      </p:sp>
-      <p:sp>
-        <p:nvSpPr>
-          <p:cNvPr id="7" name="TextBox 6"/>
-          <p:cNvSpPr txBox="1"/>
-          <p:nvPr/>
-        </p:nvSpPr>
-        <p:spPr>
-          <a:xfrm>
-            <a:off x="11594592" y="6473952"/>
-            <a:ext cx="365760" cy="274320"/>
-          </a:xfrm>
-          <a:prstGeom prst="rect">
-            <a:avLst/>
-          </a:prstGeom>
-          <a:noFill/>
-        </p:spPr>
-        <p:txBody>
-          <a:bodyPr wrap="square">
-            <a:spAutoFit/>
-          </a:bodyPr>
-          <a:lstStyle/>
-          <a:p>
-            <a:pPr algn="r"/>
-            <a:r>
-              <a:rPr sz="1000" b="0">
-                <a:solidFill>
-                  <a:srgbClr val="5A5A5A"/>
-                </a:solidFill>
-                <a:latin typeface="Calibri"/>
-              </a:rPr>
-              <a:t>8</a:t>
-            </a:r>
-          </a:p>
-        </p:txBody>
-      </p:sp>
-      <p:graphicFrame>
-        <p:nvGraphicFramePr>
-          <p:cNvPr id="8" name="Table 7"/>
-          <p:cNvGraphicFramePr>
-            <a:graphicFrameLocks noGrp="1"/>
-          </p:cNvGraphicFramePr>
-          <p:nvPr/>
-        </p:nvGraphicFramePr>
-        <p:xfrm>
-          <a:off x="292608" y="1207008"/>
-          <a:ext cx="11612880" cy="2560320"/>
-        </p:xfrm>
-        <a:graphic>
-          <a:graphicData uri="http://schemas.openxmlformats.org/drawingml/2006/table">
-            <a:tbl>
-              <a:tblPr firstRow="1" bandRow="1">
-                <a:tableStyleId>{5C22544A-7EE6-4342-B048-85BDC9FD1C3A}</a:tableStyleId>
-              </a:tblPr>
-              <a:tblGrid>
-                <a:gridCol w="2194560"/>
-                <a:gridCol w="4023360"/>
-                <a:gridCol w="2194560"/>
-                <a:gridCol w="3200400"/>
-              </a:tblGrid>
-              <a:tr h="365760">
-                <a:tc>
-                  <a:txBody>
-                    <a:bodyPr/>
-                    <a:lstStyle/>
-                    <a:p>
-                      <a:pPr algn="l"/>
-                      <a:r>
-                        <a:rPr sz="1150" b="1">
-                          <a:solidFill>
-                            <a:srgbClr val="FFFFFF"/>
-                          </a:solidFill>
-                          <a:latin typeface="Calibri"/>
-                        </a:rPr>
-                        <a:t>Part</a:t>
-                      </a:r>
-                    </a:p>
-                  </a:txBody>
-                  <a:tcPr anchor="ctr" marL="73152" marR="73152">
-                    <a:solidFill>
-                      <a:srgbClr val="CC0E1E"/>
-                    </a:solidFill>
-                  </a:tcPr>
-                </a:tc>
-                <a:tc>
-                  <a:txBody>
-                    <a:bodyPr/>
-                    <a:lstStyle/>
-                    <a:p>
-                      <a:pPr algn="l"/>
-                      <a:r>
-                        <a:rPr sz="1150" b="1">
-                          <a:solidFill>
-                            <a:srgbClr val="FFFFFF"/>
-                          </a:solidFill>
-                          <a:latin typeface="Calibri"/>
-                        </a:rPr>
-                        <a:t>Description</a:t>
-                      </a:r>
-                    </a:p>
-                  </a:txBody>
-                  <a:tcPr anchor="ctr" marL="73152" marR="73152">
-                    <a:solidFill>
-                      <a:srgbClr val="CC0E1E"/>
-                    </a:solidFill>
-                  </a:tcPr>
-                </a:tc>
-                <a:tc>
-                  <a:txBody>
-                    <a:bodyPr/>
-                    <a:lstStyle/>
-                    <a:p>
-                      <a:pPr algn="r"/>
-                      <a:r>
-                        <a:rPr sz="1150" b="1">
-                          <a:solidFill>
-                            <a:srgbClr val="FFFFFF"/>
-                          </a:solidFill>
-                          <a:latin typeface="Calibri"/>
-                        </a:rPr>
-                        <a:t>Current sales</a:t>
-                      </a:r>
-                    </a:p>
-                  </a:txBody>
-                  <a:tcPr anchor="ctr" marL="73152" marR="73152">
-                    <a:solidFill>
-                      <a:srgbClr val="CC0E1E"/>
-                    </a:solidFill>
-                  </a:tcPr>
-                </a:tc>
-                <a:tc>
-                  <a:txBody>
-                    <a:bodyPr/>
-                    <a:lstStyle/>
-                    <a:p>
-                      <a:pPr algn="l"/>
-                      <a:r>
-                        <a:rPr sz="1150" b="1">
-                          <a:solidFill>
-                            <a:srgbClr val="FFFFFF"/>
-                          </a:solidFill>
-                          <a:latin typeface="Calibri"/>
-                        </a:rPr>
-                        <a:t>Review</a:t>
-                      </a:r>
-                    </a:p>
-                  </a:txBody>
-                  <a:tcPr anchor="ctr" marL="73152" marR="73152">
-                    <a:solidFill>
-                      <a:srgbClr val="CC0E1E"/>
-                    </a:solidFill>
-                  </a:tcPr>
-                </a:tc>
-              </a:tr>
-              <a:tr h="365760">
-                <a:tc>
-                  <a:txBody>
-                    <a:bodyPr/>
-                    <a:lstStyle/>
-                    <a:p>
-                      <a:pPr algn="l"/>
-                      <a:r>
-                        <a:rPr sz="1150" b="0">
-                          <a:solidFill>
-                            <a:srgbClr val="1A1A1A"/>
-                          </a:solidFill>
-                          <a:latin typeface="Calibri"/>
-                        </a:rPr>
-                        <a:t>8978461162</a:t>
-                      </a:r>
-                    </a:p>
-                  </a:txBody>
-                  <a:tcPr anchor="ctr" marL="73152" marR="73152">
-                    <a:solidFill>
-                      <a:srgbClr val="FFFFFF"/>
-                    </a:solidFill>
-                  </a:tcPr>
-                </a:tc>
-                <a:tc>
-                  <a:txBody>
-                    <a:bodyPr/>
-                    <a:lstStyle/>
-                    <a:p>
-                      <a:pPr algn="l"/>
-                      <a:r>
-                        <a:rPr sz="1150" b="0">
-                          <a:solidFill>
-                            <a:srgbClr val="1A1A1A"/>
-                          </a:solidFill>
-                          <a:latin typeface="Calibri"/>
-                        </a:rPr>
-                        <a:t>GLASS; WINDSHIELD</a:t>
-                      </a:r>
-                    </a:p>
-                  </a:txBody>
-                  <a:tcPr anchor="ctr" marL="73152" marR="73152">
-                    <a:solidFill>
-                      <a:srgbClr val="FFFFFF"/>
-                    </a:solidFill>
-                  </a:tcPr>
-                </a:tc>
-                <a:tc>
-                  <a:txBody>
-                    <a:bodyPr/>
-                    <a:lstStyle/>
-                    <a:p>
-                      <a:pPr algn="r"/>
-                      <a:r>
-                        <a:rPr sz="1150" b="0">
-                          <a:solidFill>
-                            <a:srgbClr val="1A1A1A"/>
-                          </a:solidFill>
-                          <a:latin typeface="Calibri"/>
-                        </a:rPr>
-                        <a:t>EUR 19,705</a:t>
-                      </a:r>
-                    </a:p>
-                  </a:txBody>
-                  <a:tcPr anchor="ctr" marL="73152" marR="73152">
-                    <a:solidFill>
-                      <a:srgbClr val="FFFFFF"/>
-                    </a:solidFill>
-                  </a:tcPr>
-                </a:tc>
-                <a:tc>
-                  <a:txBody>
-                    <a:bodyPr/>
-                    <a:lstStyle/>
-                    <a:p>
-                      <a:pPr algn="l"/>
-                      <a:r>
-                        <a:rPr sz="1150" b="0">
-                          <a:solidFill>
-                            <a:srgbClr val="1A1A1A"/>
-                          </a:solidFill>
-                          <a:latin typeface="Calibri"/>
-                        </a:rPr>
-                        <a:t>Validate</a:t>
-                      </a:r>
-                    </a:p>
-                  </a:txBody>
-                  <a:tcPr anchor="ctr" marL="73152" marR="73152">
-                    <a:solidFill>
-                      <a:srgbClr val="FFFFFF"/>
-                    </a:solidFill>
-                  </a:tcPr>
-                </a:tc>
-              </a:tr>
-              <a:tr h="365760">
-                <a:tc>
-                  <a:txBody>
-                    <a:bodyPr/>
-                    <a:lstStyle/>
-                    <a:p>
-                      <a:pPr algn="l"/>
-                      <a:r>
-                        <a:rPr sz="1150" b="0">
-                          <a:solidFill>
-                            <a:srgbClr val="1A1A1A"/>
-                          </a:solidFill>
-                          <a:latin typeface="Calibri"/>
-                        </a:rPr>
-                        <a:t>7552283750</a:t>
-                      </a:r>
-                    </a:p>
-                  </a:txBody>
-                  <a:tcPr anchor="ctr" marL="73152" marR="73152">
-                    <a:solidFill>
-                      <a:srgbClr val="ECECEC"/>
-                    </a:solidFill>
-                  </a:tcPr>
-                </a:tc>
-                <a:tc>
-                  <a:txBody>
-                    <a:bodyPr/>
-                    <a:lstStyle/>
-                    <a:p>
-                      <a:pPr algn="l"/>
-                      <a:r>
-                        <a:rPr sz="1150" b="0">
-                          <a:solidFill>
-                            <a:srgbClr val="1A1A1A"/>
-                          </a:solidFill>
-                          <a:latin typeface="Calibri"/>
-                        </a:rPr>
-                        <a:t>TRANSFER ASM</a:t>
-                      </a:r>
-                    </a:p>
-                  </a:txBody>
-                  <a:tcPr anchor="ctr" marL="73152" marR="73152">
-                    <a:solidFill>
-                      <a:srgbClr val="ECECEC"/>
-                    </a:solidFill>
-                  </a:tcPr>
-                </a:tc>
-                <a:tc>
-                  <a:txBody>
-                    <a:bodyPr/>
-                    <a:lstStyle/>
-                    <a:p>
-                      <a:pPr algn="r"/>
-                      <a:r>
-                        <a:rPr sz="1150" b="0">
-                          <a:solidFill>
-                            <a:srgbClr val="1A1A1A"/>
-                          </a:solidFill>
-                          <a:latin typeface="Calibri"/>
-                        </a:rPr>
-                        <a:t>EUR 8,010</a:t>
-                      </a:r>
-                    </a:p>
-                  </a:txBody>
-                  <a:tcPr anchor="ctr" marL="73152" marR="73152">
-                    <a:solidFill>
-                      <a:srgbClr val="ECECEC"/>
-                    </a:solidFill>
-                  </a:tcPr>
-                </a:tc>
-                <a:tc>
-                  <a:txBody>
-                    <a:bodyPr/>
-                    <a:lstStyle/>
-                    <a:p>
-                      <a:pPr algn="l"/>
-                      <a:r>
-                        <a:rPr sz="1150" b="0">
-                          <a:solidFill>
-                            <a:srgbClr val="1A1A1A"/>
-                          </a:solidFill>
-                          <a:latin typeface="Calibri"/>
-                        </a:rPr>
-                        <a:t>Validate</a:t>
-                      </a:r>
-                    </a:p>
-                  </a:txBody>
-                  <a:tcPr anchor="ctr" marL="73152" marR="73152">
-                    <a:solidFill>
-                      <a:srgbClr val="ECECEC"/>
-                    </a:solidFill>
-                  </a:tcPr>
-                </a:tc>
-              </a:tr>
-              <a:tr h="365760">
-                <a:tc>
-                  <a:txBody>
-                    <a:bodyPr/>
-                    <a:lstStyle/>
-                    <a:p>
-                      <a:pPr algn="l"/>
-                      <a:r>
-                        <a:rPr sz="1150" b="0">
-                          <a:solidFill>
-                            <a:srgbClr val="1A1A1A"/>
-                          </a:solidFill>
-                          <a:latin typeface="Calibri"/>
-                        </a:rPr>
-                        <a:t>7552348310</a:t>
-                      </a:r>
-                    </a:p>
-                  </a:txBody>
-                  <a:tcPr anchor="ctr" marL="73152" marR="73152">
-                    <a:solidFill>
-                      <a:srgbClr val="FFFFFF"/>
-                    </a:solidFill>
-                  </a:tcPr>
-                </a:tc>
-                <a:tc>
-                  <a:txBody>
-                    <a:bodyPr/>
-                    <a:lstStyle/>
-                    <a:p>
-                      <a:pPr algn="l"/>
-                      <a:r>
-                        <a:rPr sz="1150" b="0">
-                          <a:solidFill>
-                            <a:srgbClr val="1A1A1A"/>
-                          </a:solidFill>
-                          <a:latin typeface="Calibri"/>
-                        </a:rPr>
-                        <a:t>STEERING UNIT</a:t>
-                      </a:r>
-                    </a:p>
-                  </a:txBody>
-                  <a:tcPr anchor="ctr" marL="73152" marR="73152">
-                    <a:solidFill>
-                      <a:srgbClr val="FFFFFF"/>
-                    </a:solidFill>
-                  </a:tcPr>
-                </a:tc>
-                <a:tc>
-                  <a:txBody>
-                    <a:bodyPr/>
-                    <a:lstStyle/>
-                    <a:p>
-                      <a:pPr algn="r"/>
-                      <a:r>
-                        <a:rPr sz="1150" b="0">
-                          <a:solidFill>
-                            <a:srgbClr val="1A1A1A"/>
-                          </a:solidFill>
-                          <a:latin typeface="Calibri"/>
-                        </a:rPr>
-                        <a:t>EUR 4,918</a:t>
-                      </a:r>
-                    </a:p>
-                  </a:txBody>
-                  <a:tcPr anchor="ctr" marL="73152" marR="73152">
-                    <a:solidFill>
-                      <a:srgbClr val="FFFFFF"/>
-                    </a:solidFill>
-                  </a:tcPr>
-                </a:tc>
-                <a:tc>
-                  <a:txBody>
-                    <a:bodyPr/>
-                    <a:lstStyle/>
-                    <a:p>
-                      <a:pPr algn="l"/>
-                      <a:r>
-                        <a:rPr sz="1150" b="0">
-                          <a:solidFill>
-                            <a:srgbClr val="1A1A1A"/>
-                          </a:solidFill>
-                          <a:latin typeface="Calibri"/>
-                        </a:rPr>
-                        <a:t>Validate</a:t>
-                      </a:r>
-                    </a:p>
-                  </a:txBody>
-                  <a:tcPr anchor="ctr" marL="73152" marR="73152">
-                    <a:solidFill>
-                      <a:srgbClr val="FFFFFF"/>
-                    </a:solidFill>
-                  </a:tcPr>
-                </a:tc>
-              </a:tr>
-              <a:tr h="365760">
-                <a:tc>
-                  <a:txBody>
-                    <a:bodyPr/>
-                    <a:lstStyle/>
-                    <a:p>
-                      <a:pPr algn="l"/>
-                      <a:r>
-                        <a:rPr sz="1150" b="0">
-                          <a:solidFill>
-                            <a:srgbClr val="1A1A1A"/>
-                          </a:solidFill>
-                          <a:latin typeface="Calibri"/>
-                        </a:rPr>
-                        <a:t>8978725102</a:t>
-                      </a:r>
-                    </a:p>
-                  </a:txBody>
-                  <a:tcPr anchor="ctr" marL="73152" marR="73152">
-                    <a:solidFill>
-                      <a:srgbClr val="ECECEC"/>
-                    </a:solidFill>
-                  </a:tcPr>
-                </a:tc>
-                <a:tc>
-                  <a:txBody>
-                    <a:bodyPr/>
-                    <a:lstStyle/>
-                    <a:p>
-                      <a:pPr algn="l"/>
-                      <a:r>
-                        <a:rPr sz="1150" b="0">
-                          <a:solidFill>
-                            <a:srgbClr val="1A1A1A"/>
-                          </a:solidFill>
-                          <a:latin typeface="Calibri"/>
-                        </a:rPr>
-                        <a:t>PANEL; SIDE OUTER</a:t>
-                      </a:r>
-                    </a:p>
-                  </a:txBody>
-                  <a:tcPr anchor="ctr" marL="73152" marR="73152">
-                    <a:solidFill>
-                      <a:srgbClr val="ECECEC"/>
-                    </a:solidFill>
-                  </a:tcPr>
-                </a:tc>
-                <a:tc>
-                  <a:txBody>
-                    <a:bodyPr/>
-                    <a:lstStyle/>
-                    <a:p>
-                      <a:pPr algn="r"/>
-                      <a:r>
-                        <a:rPr sz="1150" b="0">
-                          <a:solidFill>
-                            <a:srgbClr val="1A1A1A"/>
-                          </a:solidFill>
-                          <a:latin typeface="Calibri"/>
-                        </a:rPr>
-                        <a:t>EUR 3,741</a:t>
-                      </a:r>
-                    </a:p>
-                  </a:txBody>
-                  <a:tcPr anchor="ctr" marL="73152" marR="73152">
-                    <a:solidFill>
-                      <a:srgbClr val="ECECEC"/>
-                    </a:solidFill>
-                  </a:tcPr>
-                </a:tc>
-                <a:tc>
-                  <a:txBody>
-                    <a:bodyPr/>
-                    <a:lstStyle/>
-                    <a:p>
-                      <a:pPr algn="l"/>
-                      <a:r>
-                        <a:rPr sz="1150" b="0">
-                          <a:solidFill>
-                            <a:srgbClr val="1A1A1A"/>
-                          </a:solidFill>
-                          <a:latin typeface="Calibri"/>
-                        </a:rPr>
-                        <a:t>Validate</a:t>
-                      </a:r>
-                    </a:p>
-                  </a:txBody>
-                  <a:tcPr anchor="ctr" marL="73152" marR="73152">
-                    <a:solidFill>
-                      <a:srgbClr val="ECECEC"/>
-                    </a:solidFill>
-                  </a:tcPr>
-                </a:tc>
-              </a:tr>
-              <a:tr h="365760">
-                <a:tc>
-                  <a:txBody>
-                    <a:bodyPr/>
-                    <a:lstStyle/>
-                    <a:p>
-                      <a:pPr algn="l"/>
-                      <a:r>
-                        <a:rPr sz="1150" b="0">
-                          <a:solidFill>
-                            <a:srgbClr val="1A1A1A"/>
-                          </a:solidFill>
-                          <a:latin typeface="Calibri"/>
-                        </a:rPr>
-                        <a:t>8983042280</a:t>
-                      </a:r>
-                    </a:p>
-                  </a:txBody>
-                  <a:tcPr anchor="ctr" marL="73152" marR="73152">
-                    <a:solidFill>
-                      <a:srgbClr val="FFFFFF"/>
-                    </a:solidFill>
-                  </a:tcPr>
-                </a:tc>
-                <a:tc>
-                  <a:txBody>
-                    <a:bodyPr/>
-                    <a:lstStyle/>
-                    <a:p>
-                      <a:pPr algn="l"/>
-                      <a:r>
-                        <a:rPr sz="1150" b="0">
-                          <a:solidFill>
-                            <a:srgbClr val="1A1A1A"/>
-                          </a:solidFill>
-                          <a:latin typeface="Calibri"/>
-                        </a:rPr>
-                        <a:t>TRANSMISSION ASM; AUTO</a:t>
-                      </a:r>
-                    </a:p>
-                  </a:txBody>
-                  <a:tcPr anchor="ctr" marL="73152" marR="73152">
-                    <a:solidFill>
-                      <a:srgbClr val="FFFFFF"/>
-                    </a:solidFill>
-                  </a:tcPr>
-                </a:tc>
-                <a:tc>
-                  <a:txBody>
-                    <a:bodyPr/>
-                    <a:lstStyle/>
-                    <a:p>
-                      <a:pPr algn="r"/>
-                      <a:r>
-                        <a:rPr sz="1150" b="0">
-                          <a:solidFill>
-                            <a:srgbClr val="1A1A1A"/>
-                          </a:solidFill>
-                          <a:latin typeface="Calibri"/>
-                        </a:rPr>
-                        <a:t>EUR 3,656</a:t>
-                      </a:r>
-                    </a:p>
-                  </a:txBody>
-                  <a:tcPr anchor="ctr" marL="73152" marR="73152">
-                    <a:solidFill>
-                      <a:srgbClr val="FFFFFF"/>
-                    </a:solidFill>
-                  </a:tcPr>
-                </a:tc>
-                <a:tc>
-                  <a:txBody>
-                    <a:bodyPr/>
-                    <a:lstStyle/>
-                    <a:p>
-                      <a:pPr algn="l"/>
-                      <a:r>
-                        <a:rPr sz="1150" b="0">
-                          <a:solidFill>
-                            <a:srgbClr val="1A1A1A"/>
-                          </a:solidFill>
-                          <a:latin typeface="Calibri"/>
-                        </a:rPr>
-                        <a:t>Validate</a:t>
-                      </a:r>
-                    </a:p>
-                  </a:txBody>
-                  <a:tcPr anchor="ctr" marL="73152" marR="73152">
-                    <a:solidFill>
-                      <a:srgbClr val="FFFFFF"/>
-                    </a:solidFill>
-                  </a:tcPr>
-                </a:tc>
-              </a:tr>
-              <a:tr h="365760">
-                <a:tc>
-                  <a:txBody>
-                    <a:bodyPr/>
-                    <a:lstStyle/>
-                    <a:p>
-                      <a:pPr algn="l"/>
-                      <a:r>
-                        <a:rPr sz="1150" b="0">
-                          <a:solidFill>
-                            <a:srgbClr val="1A1A1A"/>
-                          </a:solidFill>
-                          <a:latin typeface="Calibri"/>
-                        </a:rPr>
-                        <a:t>8981596930</a:t>
-                      </a:r>
-                    </a:p>
-                  </a:txBody>
-                  <a:tcPr anchor="ctr" marL="73152" marR="73152">
-                    <a:solidFill>
-                      <a:srgbClr val="ECECEC"/>
-                    </a:solidFill>
-                  </a:tcPr>
-                </a:tc>
-                <a:tc>
-                  <a:txBody>
-                    <a:bodyPr/>
-                    <a:lstStyle/>
-                    <a:p>
-                      <a:pPr algn="l"/>
-                      <a:r>
-                        <a:rPr sz="1150" b="0">
-                          <a:solidFill>
-                            <a:srgbClr val="1A1A1A"/>
-                          </a:solidFill>
-                          <a:latin typeface="Calibri"/>
-                        </a:rPr>
-                        <a:t>ELEMENT KIT; FUEL FILTER</a:t>
-                      </a:r>
-                    </a:p>
-                  </a:txBody>
-                  <a:tcPr anchor="ctr" marL="73152" marR="73152">
-                    <a:solidFill>
-                      <a:srgbClr val="ECECEC"/>
-                    </a:solidFill>
-                  </a:tcPr>
-                </a:tc>
-                <a:tc>
-                  <a:txBody>
-                    <a:bodyPr/>
-                    <a:lstStyle/>
-                    <a:p>
-                      <a:pPr algn="r"/>
-                      <a:r>
-                        <a:rPr sz="1150" b="0">
-                          <a:solidFill>
-                            <a:srgbClr val="1A1A1A"/>
-                          </a:solidFill>
-                          <a:latin typeface="Calibri"/>
-                        </a:rPr>
-                        <a:t>EUR 3,508</a:t>
-                      </a:r>
-                    </a:p>
-                  </a:txBody>
-                  <a:tcPr anchor="ctr" marL="73152" marR="73152">
-                    <a:solidFill>
-                      <a:srgbClr val="ECECEC"/>
-                    </a:solidFill>
-                  </a:tcPr>
-                </a:tc>
-                <a:tc>
-                  <a:txBody>
-                    <a:bodyPr/>
-                    <a:lstStyle/>
-                    <a:p>
-                      <a:pPr algn="l"/>
-                      <a:r>
-                        <a:rPr sz="1150" b="0">
-                          <a:solidFill>
-                            <a:srgbClr val="1A1A1A"/>
-                          </a:solidFill>
-                          <a:latin typeface="Calibri"/>
-                        </a:rPr>
-                        <a:t>Validate</a:t>
-                      </a:r>
-                    </a:p>
-                  </a:txBody>
-                  <a:tcPr anchor="ctr" marL="73152" marR="73152">
-                    <a:solidFill>
-                      <a:srgbClr val="ECECEC"/>
-                    </a:solidFill>
-                  </a:tcPr>
-                </a:tc>
-              </a:tr>
-            </a:tbl>
-          </a:graphicData>
-        </a:graphic>
-      </p:graphicFrame>
-      <p:sp>
-        <p:nvSpPr>
-          <p:cNvPr id="9" name="TextBox 8"/>
-          <p:cNvSpPr txBox="1"/>
-          <p:nvPr/>
-        </p:nvSpPr>
-        <p:spPr>
-          <a:xfrm>
-            <a:off x="292608" y="4069080"/>
-            <a:ext cx="11612880" cy="1371600"/>
-          </a:xfrm>
-          <a:prstGeom prst="rect">
-            <a:avLst/>
-          </a:prstGeom>
-          <a:noFill/>
-        </p:spPr>
-        <p:txBody>
-          <a:bodyPr wrap="square">
-            <a:spAutoFit/>
-          </a:bodyPr>
-          <a:lstStyle/>
-          <a:p>
-            <a:pPr>
-              <a:lnSpc>
-                <a:spcPct val="125000"/>
-              </a:lnSpc>
-              <a:spcAft>
-                <a:spcPts val="1000"/>
-              </a:spcAft>
-            </a:pPr>
-            <a:r>
-              <a:rPr sz="1400" b="1">
-                <a:solidFill>
-                  <a:srgbClr val="CC0E1E"/>
-                </a:solidFill>
-                <a:latin typeface="Calibri"/>
-              </a:rPr>
-              <a:t>—  </a:t>
-            </a:r>
-            <a:r>
-              <a:rPr sz="1400">
-                <a:solidFill>
-                  <a:srgbClr val="1A1A1A"/>
-                </a:solidFill>
-                <a:latin typeface="Calibri"/>
-              </a:rPr>
-              <a:t>These lines had no prior-period sales, so they are kept out of the incremental-growth table.</a:t>
-            </a:r>
-          </a:p>
-          <a:p>
-            <a:pPr>
-              <a:lnSpc>
-                <a:spcPct val="125000"/>
-              </a:lnSpc>
-              <a:spcAft>
-                <a:spcPts val="1000"/>
-              </a:spcAft>
-            </a:pPr>
-            <a:r>
-              <a:rPr sz="1400" b="1">
-                <a:solidFill>
-                  <a:srgbClr val="CC0E1E"/>
-                </a:solidFill>
-                <a:latin typeface="Calibri"/>
-              </a:rPr>
-              <a:t>—  </a:t>
-            </a:r>
-            <a:r>
-              <a:rPr sz="1400">
-                <a:solidFill>
-                  <a:srgbClr val="1A1A1A"/>
-                </a:solidFill>
-                <a:latin typeface="Calibri"/>
-              </a:rPr>
-              <a:t>A first sale can be a new model, a supersession, timing, or a warranty campaign. It is not treated as a commercial win until that cause is confirmed.</a:t>
-            </a:r>
-          </a:p>
-        </p:txBody>
-      </p:sp>
-    </p:spTree>
-  </p:cSld>
-  <p:clrMapOvr>
-    <a:masterClrMapping/>
-  </p:clrMapOvr>
-</p:sld>
-</file>
-
-<file path=ppt/slides/slide9.xml><?xml version="1.0" encoding="utf-8"?>
-<p:sld xmlns:a="http://schemas.openxmlformats.org/drawingml/2006/main" xmlns:p="http://schemas.openxmlformats.org/presentationml/2006/main" xmlns:r="http://schemas.openxmlformats.org/officeDocument/2006/relationships">
-  <p:cSld>
-    <p:bg>
-      <p:bgPr>
-        <a:solidFill>
-          <a:srgbClr val="FFFFFF"/>
-        </a:solidFill>
-        <a:effectLst/>
-      </p:bgPr>
-    </p:bg>
-    <p:spTree>
-      <p:nvGrpSpPr>
-        <p:cNvPr id="1" name=""/>
-        <p:cNvGrpSpPr/>
-        <p:nvPr/>
-      </p:nvGrpSpPr>
-      <p:grpSpPr/>
-      <p:pic>
-        <p:nvPicPr>
-          <p:cNvPr id="2" name="Picture 1" descr="isuzu_logo_red.png"/>
-          <p:cNvPicPr>
-            <a:picLocks noChangeAspect="1"/>
-          </p:cNvPicPr>
-          <p:nvPr/>
-        </p:nvPicPr>
-        <p:blipFill>
-          <a:blip r:embed="rId2"/>
-          <a:stretch>
-            <a:fillRect/>
-          </a:stretch>
-        </p:blipFill>
-        <p:spPr>
-          <a:xfrm>
-            <a:off x="256032" y="6263640"/>
-            <a:ext cx="1679787" cy="292608"/>
-          </a:xfrm>
-          <a:prstGeom prst="rect">
-            <a:avLst/>
-          </a:prstGeom>
-        </p:spPr>
-      </p:pic>
-      <p:sp>
-        <p:nvSpPr>
-          <p:cNvPr id="3" name="Rectangle 2"/>
-          <p:cNvSpPr/>
-          <p:nvPr/>
-        </p:nvSpPr>
-        <p:spPr>
-          <a:xfrm>
-            <a:off x="0" y="6766560"/>
-            <a:ext cx="12188952" cy="91440"/>
-          </a:xfrm>
-          <a:prstGeom prst="rect">
-            <a:avLst/>
-          </a:prstGeom>
-          <a:solidFill>
-            <a:srgbClr val="CC0E1E"/>
-          </a:solidFill>
-          <a:ln>
-            <a:noFill/>
-          </a:ln>
-        </p:spPr>
-        <p:style>
-          <a:lnRef idx="1">
-            <a:schemeClr val="accent1"/>
-          </a:lnRef>
-          <a:fillRef idx="3">
-            <a:schemeClr val="accent1"/>
-          </a:fillRef>
-          <a:effectRef idx="2">
-            <a:schemeClr val="accent1"/>
-          </a:effectRef>
-          <a:fontRef idx="minor">
-            <a:schemeClr val="lt1"/>
-          </a:fontRef>
-        </p:style>
-        <p:txBody>
-          <a:bodyPr rtlCol="0" anchor="ctr"/>
-          <a:lstStyle/>
-          <a:p>
-            <a:pPr algn="ctr"/>
-          </a:p>
-        </p:txBody>
-      </p:sp>
-      <p:sp>
-        <p:nvSpPr>
-          <p:cNvPr id="4" name="TextBox 3"/>
-          <p:cNvSpPr txBox="1"/>
-          <p:nvPr/>
-        </p:nvSpPr>
-        <p:spPr>
-          <a:xfrm>
-            <a:off x="292608" y="201168"/>
-            <a:ext cx="11430000" cy="274320"/>
-          </a:xfrm>
-          <a:prstGeom prst="rect">
-            <a:avLst/>
-          </a:prstGeom>
-          <a:noFill/>
-        </p:spPr>
-        <p:txBody>
-          <a:bodyPr wrap="square">
-            <a:spAutoFit/>
-          </a:bodyPr>
-          <a:lstStyle/>
-          <a:p>
-            <a:pPr algn="l"/>
-            <a:r>
-              <a:rPr sz="1100" b="1">
-                <a:solidFill>
-                  <a:srgbClr val="CC0E1E"/>
-                </a:solidFill>
-                <a:latin typeface="Calibri"/>
-              </a:rPr>
-              <a:t>SALES-TO-DEALER</a:t>
-            </a:r>
-          </a:p>
-        </p:txBody>
-      </p:sp>
-      <p:sp>
-        <p:nvSpPr>
-          <p:cNvPr id="5" name="TextBox 4"/>
-          <p:cNvSpPr txBox="1"/>
-          <p:nvPr/>
-        </p:nvSpPr>
-        <p:spPr>
-          <a:xfrm>
-            <a:off x="292608" y="475488"/>
-            <a:ext cx="11612880" cy="566928"/>
-          </a:xfrm>
-          <a:prstGeom prst="rect">
-            <a:avLst/>
-          </a:prstGeom>
-          <a:noFill/>
-        </p:spPr>
-        <p:txBody>
-          <a:bodyPr wrap="square">
-            <a:spAutoFit/>
-          </a:bodyPr>
-          <a:lstStyle/>
-          <a:p>
-            <a:pPr algn="l"/>
-            <a:r>
-              <a:rPr sz="2500" b="1">
-                <a:solidFill>
-                  <a:srgbClr val="1A1A1A"/>
-                </a:solidFill>
-                <a:latin typeface="Calibri"/>
-              </a:rPr>
-              <a:t>Sales-to-Dealer outlook — FY2027</a:t>
-            </a:r>
-          </a:p>
-        </p:txBody>
-      </p:sp>
-      <p:sp>
-        <p:nvSpPr>
-          <p:cNvPr id="6" name="Rectangle 5"/>
-          <p:cNvSpPr/>
-          <p:nvPr/>
-        </p:nvSpPr>
-        <p:spPr>
-          <a:xfrm>
-            <a:off x="292608" y="1005840"/>
-            <a:ext cx="11612880" cy="28000"/>
-          </a:xfrm>
-          <a:prstGeom prst="rect">
-            <a:avLst/>
-          </a:prstGeom>
-          <a:solidFill>
-            <a:srgbClr val="CC0E1E"/>
-          </a:solidFill>
-          <a:ln>
-            <a:noFill/>
-          </a:ln>
-        </p:spPr>
-        <p:style>
-          <a:lnRef idx="1">
-            <a:schemeClr val="accent1"/>
-          </a:lnRef>
-          <a:fillRef idx="3">
-            <a:schemeClr val="accent1"/>
-          </a:fillRef>
-          <a:effectRef idx="2">
-            <a:schemeClr val="accent1"/>
-          </a:effectRef>
-          <a:fontRef idx="minor">
-            <a:schemeClr val="lt1"/>
-          </a:fontRef>
-        </p:style>
-        <p:txBody>
-          <a:bodyPr rtlCol="0" anchor="ctr"/>
-          <a:lstStyle/>
-          <a:p>
-            <a:pPr algn="ctr"/>
-          </a:p>
-        </p:txBody>
-      </p:sp>
-      <p:sp>
-        <p:nvSpPr>
-          <p:cNvPr id="7" name="TextBox 6"/>
-          <p:cNvSpPr txBox="1"/>
-          <p:nvPr/>
-        </p:nvSpPr>
-        <p:spPr>
-          <a:xfrm>
-            <a:off x="11594592" y="6473952"/>
-            <a:ext cx="365760" cy="274320"/>
-          </a:xfrm>
-          <a:prstGeom prst="rect">
-            <a:avLst/>
-          </a:prstGeom>
-          <a:noFill/>
-        </p:spPr>
-        <p:txBody>
-          <a:bodyPr wrap="square">
-            <a:spAutoFit/>
-          </a:bodyPr>
-          <a:lstStyle/>
-          <a:p>
-            <a:pPr algn="r"/>
-            <a:r>
-              <a:rPr sz="1000" b="0">
-                <a:solidFill>
-                  <a:srgbClr val="5A5A5A"/>
-                </a:solidFill>
-                <a:latin typeface="Calibri"/>
-              </a:rPr>
-              <a:t>9</a:t>
-            </a:r>
-          </a:p>
-        </p:txBody>
-      </p:sp>
-      <p:sp>
-        <p:nvSpPr>
-          <p:cNvPr id="8" name="TextBox 7"/>
-          <p:cNvSpPr txBox="1"/>
-          <p:nvPr/>
-        </p:nvSpPr>
-        <p:spPr>
-          <a:xfrm>
-            <a:off x="292608" y="1234440"/>
-            <a:ext cx="10881360" cy="3840480"/>
-          </a:xfrm>
-          <a:prstGeom prst="rect">
-            <a:avLst/>
-          </a:prstGeom>
-          <a:noFill/>
-        </p:spPr>
-        <p:txBody>
-          <a:bodyPr wrap="square">
-            <a:spAutoFit/>
-          </a:bodyPr>
-          <a:lstStyle/>
-          <a:p>
-            <a:pPr>
-              <a:lnSpc>
-                <a:spcPct val="125000"/>
-              </a:lnSpc>
-              <a:spcAft>
-                <a:spcPts val="1000"/>
-              </a:spcAft>
-            </a:pPr>
-            <a:r>
-              <a:rPr sz="1500" b="1">
-                <a:solidFill>
-                  <a:srgbClr val="CC0E1E"/>
-                </a:solidFill>
-                <a:latin typeface="Calibri"/>
-              </a:rPr>
-              <a:t>—  </a:t>
-            </a:r>
-            <a:r>
-              <a:rPr sz="1500">
-                <a:solidFill>
-                  <a:srgbClr val="1A1A1A"/>
-                </a:solidFill>
-                <a:latin typeface="Calibri"/>
-              </a:rPr>
-              <a:t>FY2026 Sales-to-Dealer is EUR 6,834,272 (reported KPI).</a:t>
-            </a:r>
-          </a:p>
-          <a:p>
-            <a:pPr>
-              <a:lnSpc>
-                <a:spcPct val="125000"/>
-              </a:lnSpc>
-              <a:spcAft>
-                <a:spcPts val="1000"/>
-              </a:spcAft>
-            </a:pPr>
-            <a:r>
-              <a:rPr sz="1500" b="1">
-                <a:solidFill>
-                  <a:srgbClr val="CC0E1E"/>
-                </a:solidFill>
-                <a:latin typeface="Calibri"/>
-              </a:rPr>
-              <a:t>—  </a:t>
-            </a:r>
-            <a:r>
-              <a:rPr sz="1500">
-                <a:solidFill>
-                  <a:srgbClr val="1A1A1A"/>
-                </a:solidFill>
-                <a:latin typeface="Calibri"/>
-              </a:rPr>
-              <a:t>The working fleet movement into FY2027 is -3.2%.</a:t>
-            </a:r>
-          </a:p>
-          <a:p>
-            <a:pPr>
-              <a:lnSpc>
-                <a:spcPct val="125000"/>
-              </a:lnSpc>
-              <a:spcAft>
-                <a:spcPts val="1000"/>
-              </a:spcAft>
-            </a:pPr>
-            <a:r>
-              <a:rPr sz="1500" b="1">
-                <a:solidFill>
-                  <a:srgbClr val="CC0E1E"/>
-                </a:solidFill>
-                <a:latin typeface="Calibri"/>
-              </a:rPr>
-              <a:t>—  </a:t>
-            </a:r>
-            <a:r>
-              <a:rPr sz="1500">
-                <a:solidFill>
-                  <a:srgbClr val="1A1A1A"/>
-                </a:solidFill>
-                <a:latin typeface="Calibri"/>
-              </a:rPr>
-              <a:t>Applying fleet movement, the 5% price adjustment and 1.8% additional growth gives a FY2027 Sales-to-Dealer target of EUR 7,074,416.</a:t>
-            </a:r>
-          </a:p>
-          <a:p>
-            <a:pPr>
-              <a:lnSpc>
-                <a:spcPct val="125000"/>
-              </a:lnSpc>
-              <a:spcAft>
-                <a:spcPts val="1000"/>
-              </a:spcAft>
-            </a:pPr>
-            <a:r>
-              <a:rPr sz="1500" b="1">
-                <a:solidFill>
-                  <a:srgbClr val="CC0E1E"/>
-                </a:solidFill>
-                <a:latin typeface="Calibri"/>
-              </a:rPr>
-              <a:t>—  </a:t>
-            </a:r>
-            <a:r>
-              <a:rPr sz="1500">
-                <a:solidFill>
-                  <a:srgbClr val="1A1A1A"/>
-                </a:solidFill>
-                <a:latin typeface="Calibri"/>
-              </a:rPr>
-              <a:t>The discussion is held in Sales-to-Dealer amounts; ISZE billing remains an internal reconciliation measure.</a:t>
-            </a:r>
-          </a:p>
-        </p:txBody>
-      </p:sp>
-    </p:spTree>
-  </p:cSld>
-  <p:clrMapOvr>
-    <a:masterClrMapping/>
-  </p:clrMapOvr>
-</p:sld>
-</file>
-
 <file path=ppt/theme/theme1.xml><?xml version="1.0" encoding="utf-8"?>
 <a:theme xmlns:a="http://schemas.openxmlformats.org/drawingml/2006/main" name="Office Theme">
   <a:themeElements>

</xml_diff>